<commit_message>
Replace placeholders in presentations with actual embedded Workflow Diagrams and Confusion Matrices, and update final submission Zip
</commit_message>
<xml_diff>
--- a/Final_Internship_Submission/Project_1_Fake_News/fake_news_project_ppt.pptx
+++ b/Final_Internship_Submission/Project_1_Fake_News/fake_news_project_ppt.pptx
@@ -3356,7 +3356,12 @@
             <p:ph type="title"/>
           </p:nvPr>
         </p:nvSpPr>
-        <p:spPr/>
+        <p:spPr>
+          <a:xfrm>
+            <a:off x="457201" y="204787"/>
+            <a:ext cx="3008313" cy="871538"/>
+          </a:xfrm>
+        </p:spPr>
         <p:txBody>
           <a:bodyPr/>
           <a:lstStyle/>
@@ -3373,12 +3378,12 @@
       </p:sp>
       <p:sp>
         <p:nvSpPr>
-          <p:cNvPr id="3" name="Content Placeholder 2"/>
-          <p:cNvSpPr>
-            <a:spLocks noGrp="1"/>
-          </p:cNvSpPr>
-          <p:nvPr>
-            <p:ph idx="1"/>
+          <p:cNvPr id="4" name="Text Placeholder 3"/>
+          <p:cNvSpPr>
+            <a:spLocks noGrp="1"/>
+          </p:cNvSpPr>
+          <p:nvPr>
+            <p:ph idx="2" sz="half" type="body"/>
           </p:nvPr>
         </p:nvSpPr>
         <p:spPr/>
@@ -3446,17 +3451,38 @@
               <a:t> Deploying the best model in an interactive web interface.</a:t>
             </a:r>
           </a:p>
-          <a:p>
-            <a:pPr lvl="0" indent="0" marL="0">
-              <a:buNone/>
-            </a:pPr>
-            <a:r>
-              <a:rPr i="1"/>
-              <a:t>(Include the Workflow Diagram from the report here)</a:t>
-            </a:r>
-          </a:p>
-        </p:txBody>
-      </p:sp>
+        </p:txBody>
+      </p:sp>
+      <p:pic>
+        <p:nvPicPr>
+          <p:cNvPr descr="../workflow_diagram.png" id="0" name="Picture 1"/>
+          <p:cNvPicPr>
+            <a:picLocks noGrp="1" noChangeAspect="1"/>
+          </p:cNvPicPr>
+          <p:nvPr/>
+        </p:nvPicPr>
+        <p:blipFill>
+          <a:blip r:embed="rId2"/>
+          <a:stretch>
+            <a:fillRect/>
+          </a:stretch>
+        </p:blipFill>
+        <p:spPr bwMode="auto">
+          <a:xfrm>
+            <a:off x="3568700" y="863600"/>
+            <a:ext cx="5105400" cy="3060700"/>
+          </a:xfrm>
+          <a:prstGeom prst="rect">
+            <a:avLst/>
+          </a:prstGeom>
+          <a:noFill/>
+          <a:ln w="9525">
+            <a:noFill/>
+            <a:headEnd/>
+            <a:tailEnd/>
+          </a:ln>
+        </p:spPr>
+      </p:pic>
     </p:spTree>
   </p:cSld>
 </p:sld>

</xml_diff>

<commit_message>
Update zip files with new report formatting
</commit_message>
<xml_diff>
--- a/Final_Internship_Submission/Project_1_Fake_News/fake_news_project_ppt.pptx
+++ b/Final_Internship_Submission/Project_1_Fake_News/fake_news_project_ppt.pptx
@@ -1,27 +1,24 @@
 
 <file path=ppt/presentation.xml><?xml version="1.0" encoding="utf-8"?>
-<p:presentation xmlns:a="http://schemas.openxmlformats.org/drawingml/2006/main" xmlns:p="http://schemas.openxmlformats.org/presentationml/2006/main" xmlns:r="http://schemas.openxmlformats.org/officeDocument/2006/relationships" autoCompressPictures="0" saveSubsetFonts="1">
+<p:presentation xmlns:a="http://schemas.openxmlformats.org/drawingml/2006/main" xmlns:r="http://schemas.openxmlformats.org/officeDocument/2006/relationships" xmlns:p="http://schemas.openxmlformats.org/presentationml/2006/main" saveSubsetFonts="1" autoCompressPictures="0">
   <p:sldMasterIdLst>
     <p:sldMasterId id="2147483648" r:id="rId1"/>
   </p:sldMasterIdLst>
   <p:sldIdLst>
-    <p:sldId id="256" r:id="rId2"/>
-    <p:sldId id="257" r:id="rId3"/>
-    <p:sldId id="258" r:id="rId4"/>
-    <p:sldId id="259" r:id="rId5"/>
-    <p:sldId id="260" r:id="rId6"/>
-    <p:sldId id="261" r:id="rId7"/>
-    <p:sldId id="262" r:id="rId8"/>
-    <p:sldId id="263" r:id="rId9"/>
+    <p:sldId id="256" r:id="rId7"/>
+    <p:sldId id="257" r:id="rId8"/>
+    <p:sldId id="258" r:id="rId9"/>
+    <p:sldId id="259" r:id="rId10"/>
+    <p:sldId id="260" r:id="rId11"/>
   </p:sldIdLst>
-  <p:sldSz cx="9144000" cy="5143500" type="screen16x9"/>
+  <p:sldSz cx="9144000" cy="6858000" type="screen4x3"/>
   <p:notesSz cx="6858000" cy="9144000"/>
   <p:defaultTextStyle>
     <a:defPPr>
       <a:defRPr lang="en-US"/>
     </a:defPPr>
-    <a:lvl1pPr algn="l" defTabSz="457200" eaLnBrk="1" hangingPunct="1" latinLnBrk="0" marL="0" rtl="0">
-      <a:defRPr kern="1200" sz="1800">
+    <a:lvl1pPr marL="0" algn="l" defTabSz="457200" rtl="0" eaLnBrk="1" latinLnBrk="0" hangingPunct="1">
+      <a:defRPr sz="1800" kern="1200">
         <a:solidFill>
           <a:schemeClr val="tx1"/>
         </a:solidFill>
@@ -30,8 +27,8 @@
         <a:cs typeface="+mn-cs"/>
       </a:defRPr>
     </a:lvl1pPr>
-    <a:lvl2pPr algn="l" defTabSz="457200" eaLnBrk="1" hangingPunct="1" latinLnBrk="0" marL="457200" rtl="0">
-      <a:defRPr kern="1200" sz="1800">
+    <a:lvl2pPr marL="457200" algn="l" defTabSz="457200" rtl="0" eaLnBrk="1" latinLnBrk="0" hangingPunct="1">
+      <a:defRPr sz="1800" kern="1200">
         <a:solidFill>
           <a:schemeClr val="tx1"/>
         </a:solidFill>
@@ -40,8 +37,8 @@
         <a:cs typeface="+mn-cs"/>
       </a:defRPr>
     </a:lvl2pPr>
-    <a:lvl3pPr algn="l" defTabSz="457200" eaLnBrk="1" hangingPunct="1" latinLnBrk="0" marL="914400" rtl="0">
-      <a:defRPr kern="1200" sz="1800">
+    <a:lvl3pPr marL="914400" algn="l" defTabSz="457200" rtl="0" eaLnBrk="1" latinLnBrk="0" hangingPunct="1">
+      <a:defRPr sz="1800" kern="1200">
         <a:solidFill>
           <a:schemeClr val="tx1"/>
         </a:solidFill>
@@ -50,8 +47,8 @@
         <a:cs typeface="+mn-cs"/>
       </a:defRPr>
     </a:lvl3pPr>
-    <a:lvl4pPr algn="l" defTabSz="457200" eaLnBrk="1" hangingPunct="1" latinLnBrk="0" marL="1371600" rtl="0">
-      <a:defRPr kern="1200" sz="1800">
+    <a:lvl4pPr marL="1371600" algn="l" defTabSz="457200" rtl="0" eaLnBrk="1" latinLnBrk="0" hangingPunct="1">
+      <a:defRPr sz="1800" kern="1200">
         <a:solidFill>
           <a:schemeClr val="tx1"/>
         </a:solidFill>
@@ -60,8 +57,8 @@
         <a:cs typeface="+mn-cs"/>
       </a:defRPr>
     </a:lvl4pPr>
-    <a:lvl5pPr algn="l" defTabSz="457200" eaLnBrk="1" hangingPunct="1" latinLnBrk="0" marL="1828800" rtl="0">
-      <a:defRPr kern="1200" sz="1800">
+    <a:lvl5pPr marL="1828800" algn="l" defTabSz="457200" rtl="0" eaLnBrk="1" latinLnBrk="0" hangingPunct="1">
+      <a:defRPr sz="1800" kern="1200">
         <a:solidFill>
           <a:schemeClr val="tx1"/>
         </a:solidFill>
@@ -70,8 +67,8 @@
         <a:cs typeface="+mn-cs"/>
       </a:defRPr>
     </a:lvl5pPr>
-    <a:lvl6pPr algn="l" defTabSz="457200" eaLnBrk="1" hangingPunct="1" latinLnBrk="0" marL="2286000" rtl="0">
-      <a:defRPr kern="1200" sz="1800">
+    <a:lvl6pPr marL="2286000" algn="l" defTabSz="457200" rtl="0" eaLnBrk="1" latinLnBrk="0" hangingPunct="1">
+      <a:defRPr sz="1800" kern="1200">
         <a:solidFill>
           <a:schemeClr val="tx1"/>
         </a:solidFill>
@@ -80,8 +77,8 @@
         <a:cs typeface="+mn-cs"/>
       </a:defRPr>
     </a:lvl6pPr>
-    <a:lvl7pPr algn="l" defTabSz="457200" eaLnBrk="1" hangingPunct="1" latinLnBrk="0" marL="2743200" rtl="0">
-      <a:defRPr kern="1200" sz="1800">
+    <a:lvl7pPr marL="2743200" algn="l" defTabSz="457200" rtl="0" eaLnBrk="1" latinLnBrk="0" hangingPunct="1">
+      <a:defRPr sz="1800" kern="1200">
         <a:solidFill>
           <a:schemeClr val="tx1"/>
         </a:solidFill>
@@ -90,8 +87,8 @@
         <a:cs typeface="+mn-cs"/>
       </a:defRPr>
     </a:lvl7pPr>
-    <a:lvl8pPr algn="l" defTabSz="457200" eaLnBrk="1" hangingPunct="1" latinLnBrk="0" marL="3200400" rtl="0">
-      <a:defRPr kern="1200" sz="1800">
+    <a:lvl8pPr marL="3200400" algn="l" defTabSz="457200" rtl="0" eaLnBrk="1" latinLnBrk="0" hangingPunct="1">
+      <a:defRPr sz="1800" kern="1200">
         <a:solidFill>
           <a:schemeClr val="tx1"/>
         </a:solidFill>
@@ -100,8 +97,8 @@
         <a:cs typeface="+mn-cs"/>
       </a:defRPr>
     </a:lvl8pPr>
-    <a:lvl9pPr algn="l" defTabSz="457200" eaLnBrk="1" hangingPunct="1" latinLnBrk="0" marL="3657600" rtl="0">
-      <a:defRPr kern="1200" sz="1800">
+    <a:lvl9pPr marL="3657600" algn="l" defTabSz="457200" rtl="0" eaLnBrk="1" latinLnBrk="0" hangingPunct="1">
+      <a:defRPr sz="1800" kern="1200">
         <a:solidFill>
           <a:schemeClr val="tx1"/>
         </a:solidFill>
@@ -111,22 +108,6 @@
       </a:defRPr>
     </a:lvl9pPr>
   </p:defaultTextStyle>
-  <p:extLst>
-    <p:ext uri="{EFAFB233-063F-42B5-8137-9DF3F51BA10A}">
-      <p15:sldGuideLst xmlns:p15="http://schemas.microsoft.com/office/powerpoint/2012/main">
-        <p15:guide id="1" orient="horz" pos="1620" userDrawn="1">
-          <p15:clr>
-            <a:srgbClr val="A4A3A4"/>
-          </p15:clr>
-        </p15:guide>
-        <p15:guide id="2" pos="2880" userDrawn="1">
-          <p15:clr>
-            <a:srgbClr val="A4A3A4"/>
-          </p15:clr>
-        </p15:guide>
-      </p15:sldGuideLst>
-    </p:ext>
-  </p:extLst>
 </p:presentation>
 </file>
 
@@ -159,8 +140,8 @@
         </p:nvSpPr>
         <p:spPr>
           <a:xfrm>
-            <a:off x="685800" y="1597819"/>
-            <a:ext cx="7772400" cy="1102519"/>
+            <a:off x="685800" y="2130425"/>
+            <a:ext cx="7772400" cy="1470025"/>
           </a:xfrm>
         </p:spPr>
         <p:txBody>
@@ -168,9 +149,10 @@
           <a:lstStyle/>
           <a:p>
             <a:r>
-              <a:rPr lang="en-US"/>
+              <a:rPr lang="en-US" smtClean="0"/>
               <a:t>Click to edit Master title style</a:t>
             </a:r>
+            <a:endParaRPr lang="en-US"/>
           </a:p>
         </p:txBody>
       </p:sp>
@@ -186,8 +168,8 @@
         </p:nvSpPr>
         <p:spPr>
           <a:xfrm>
-            <a:off x="1371600" y="2914650"/>
-            <a:ext cx="6400800" cy="1314450"/>
+            <a:off x="1371600" y="3886200"/>
+            <a:ext cx="6400800" cy="1752600"/>
           </a:xfrm>
         </p:spPr>
         <p:txBody>
@@ -203,7 +185,7 @@
                 </a:solidFill>
               </a:defRPr>
             </a:lvl1pPr>
-            <a:lvl2pPr marL="342900" indent="0" algn="ctr">
+            <a:lvl2pPr marL="457200" indent="0" algn="ctr">
               <a:buNone/>
               <a:defRPr>
                 <a:solidFill>
@@ -213,7 +195,7 @@
                 </a:solidFill>
               </a:defRPr>
             </a:lvl2pPr>
-            <a:lvl3pPr marL="685800" indent="0" algn="ctr">
+            <a:lvl3pPr marL="914400" indent="0" algn="ctr">
               <a:buNone/>
               <a:defRPr>
                 <a:solidFill>
@@ -223,7 +205,7 @@
                 </a:solidFill>
               </a:defRPr>
             </a:lvl3pPr>
-            <a:lvl4pPr marL="1028700" indent="0" algn="ctr">
+            <a:lvl4pPr marL="1371600" indent="0" algn="ctr">
               <a:buNone/>
               <a:defRPr>
                 <a:solidFill>
@@ -233,7 +215,7 @@
                 </a:solidFill>
               </a:defRPr>
             </a:lvl4pPr>
-            <a:lvl5pPr marL="1371600" indent="0" algn="ctr">
+            <a:lvl5pPr marL="1828800" indent="0" algn="ctr">
               <a:buNone/>
               <a:defRPr>
                 <a:solidFill>
@@ -243,7 +225,7 @@
                 </a:solidFill>
               </a:defRPr>
             </a:lvl5pPr>
-            <a:lvl6pPr marL="1714500" indent="0" algn="ctr">
+            <a:lvl6pPr marL="2286000" indent="0" algn="ctr">
               <a:buNone/>
               <a:defRPr>
                 <a:solidFill>
@@ -253,7 +235,7 @@
                 </a:solidFill>
               </a:defRPr>
             </a:lvl6pPr>
-            <a:lvl7pPr marL="2057400" indent="0" algn="ctr">
+            <a:lvl7pPr marL="2743200" indent="0" algn="ctr">
               <a:buNone/>
               <a:defRPr>
                 <a:solidFill>
@@ -263,7 +245,7 @@
                 </a:solidFill>
               </a:defRPr>
             </a:lvl7pPr>
-            <a:lvl8pPr marL="2400300" indent="0" algn="ctr">
+            <a:lvl8pPr marL="3200400" indent="0" algn="ctr">
               <a:buNone/>
               <a:defRPr>
                 <a:solidFill>
@@ -273,7 +255,7 @@
                 </a:solidFill>
               </a:defRPr>
             </a:lvl8pPr>
-            <a:lvl9pPr marL="2743200" indent="0" algn="ctr">
+            <a:lvl9pPr marL="3657600" indent="0" algn="ctr">
               <a:buNone/>
               <a:defRPr>
                 <a:solidFill>
@@ -286,9 +268,10 @@
           </a:lstStyle>
           <a:p>
             <a:r>
-              <a:rPr lang="en-US"/>
+              <a:rPr lang="en-US" smtClean="0"/>
               <a:t>Click to edit Master subtitle style</a:t>
             </a:r>
+            <a:endParaRPr lang="en-US"/>
           </a:p>
         </p:txBody>
       </p:sp>
@@ -307,9 +290,9 @@
           <a:bodyPr/>
           <a:lstStyle/>
           <a:p>
-            <a:fld id="{241EB5C9-1307-BA42-ABA2-0BC069CD8E7F}" type="datetimeFigureOut">
-              <a:rPr lang="en-US" smtClean="0"/>
-              <a:t>1/2/22</a:t>
+            <a:fld id="{5BCAD085-E8A6-8845-BD4E-CB4CCA059FC4}" type="datetimeFigureOut">
+              <a:rPr lang="en-US" smtClean="0"/>
+              <a:t>1/27/13</a:t>
             </a:fld>
             <a:endParaRPr lang="en-US"/>
           </a:p>
@@ -349,7 +332,7 @@
           <a:bodyPr/>
           <a:lstStyle/>
           <a:p>
-            <a:fld id="{C5EF2332-01BF-834F-8236-50238282D533}" type="slidenum">
+            <a:fld id="{C1FF6DA9-008F-8B48-92A6-B652298478BF}" type="slidenum">
               <a:rPr lang="en-US" smtClean="0"/>
               <a:t>‹#›</a:t>
             </a:fld>
@@ -360,7 +343,7 @@
     </p:spTree>
     <p:extLst>
       <p:ext uri="{BB962C8B-B14F-4D97-AF65-F5344CB8AC3E}">
-        <p14:creationId xmlns:p14="http://schemas.microsoft.com/office/powerpoint/2010/main" val="1444357513"/>
+        <p14:creationId xmlns:p14="http://schemas.microsoft.com/office/powerpoint/2010/main" val="3168075583"/>
       </p:ext>
     </p:extLst>
   </p:cSld>
@@ -403,9 +386,10 @@
           <a:lstStyle/>
           <a:p>
             <a:r>
-              <a:rPr lang="en-US"/>
+              <a:rPr lang="en-US" smtClean="0"/>
               <a:t>Click to edit Master title style</a:t>
             </a:r>
+            <a:endParaRPr lang="en-US"/>
           </a:p>
         </p:txBody>
       </p:sp>
@@ -426,37 +410,38 @@
           <a:p>
             <a:pPr lvl="0"/>
             <a:r>
-              <a:rPr lang="en-US"/>
+              <a:rPr lang="en-US" smtClean="0"/>
               <a:t>Click to edit Master text styles</a:t>
             </a:r>
           </a:p>
           <a:p>
             <a:pPr lvl="1"/>
             <a:r>
-              <a:rPr lang="en-US"/>
+              <a:rPr lang="en-US" smtClean="0"/>
               <a:t>Second level</a:t>
             </a:r>
           </a:p>
           <a:p>
             <a:pPr lvl="2"/>
             <a:r>
-              <a:rPr lang="en-US"/>
+              <a:rPr lang="en-US" smtClean="0"/>
               <a:t>Third level</a:t>
             </a:r>
           </a:p>
           <a:p>
             <a:pPr lvl="3"/>
             <a:r>
-              <a:rPr lang="en-US"/>
+              <a:rPr lang="en-US" smtClean="0"/>
               <a:t>Fourth level</a:t>
             </a:r>
           </a:p>
           <a:p>
             <a:pPr lvl="4"/>
             <a:r>
-              <a:rPr lang="en-US"/>
+              <a:rPr lang="en-US" smtClean="0"/>
               <a:t>Fifth level</a:t>
             </a:r>
+            <a:endParaRPr lang="en-US"/>
           </a:p>
         </p:txBody>
       </p:sp>
@@ -475,9 +460,9 @@
           <a:bodyPr/>
           <a:lstStyle/>
           <a:p>
-            <a:fld id="{241EB5C9-1307-BA42-ABA2-0BC069CD8E7F}" type="datetimeFigureOut">
-              <a:rPr lang="en-US" smtClean="0"/>
-              <a:t>1/2/22</a:t>
+            <a:fld id="{5BCAD085-E8A6-8845-BD4E-CB4CCA059FC4}" type="datetimeFigureOut">
+              <a:rPr lang="en-US" smtClean="0"/>
+              <a:t>1/27/13</a:t>
             </a:fld>
             <a:endParaRPr lang="en-US"/>
           </a:p>
@@ -517,7 +502,7 @@
           <a:bodyPr/>
           <a:lstStyle/>
           <a:p>
-            <a:fld id="{C5EF2332-01BF-834F-8236-50238282D533}" type="slidenum">
+            <a:fld id="{C1FF6DA9-008F-8B48-92A6-B652298478BF}" type="slidenum">
               <a:rPr lang="en-US" smtClean="0"/>
               <a:t>‹#›</a:t>
             </a:fld>
@@ -528,7 +513,7 @@
     </p:spTree>
     <p:extLst>
       <p:ext uri="{BB962C8B-B14F-4D97-AF65-F5344CB8AC3E}">
-        <p14:creationId xmlns:p14="http://schemas.microsoft.com/office/powerpoint/2010/main" val="313914798"/>
+        <p14:creationId xmlns:p14="http://schemas.microsoft.com/office/powerpoint/2010/main" val="2910927964"/>
       </p:ext>
     </p:extLst>
   </p:cSld>
@@ -567,8 +552,8 @@
         </p:nvSpPr>
         <p:spPr>
           <a:xfrm>
-            <a:off x="6629400" y="205979"/>
-            <a:ext cx="2057400" cy="4388644"/>
+            <a:off x="6629400" y="274638"/>
+            <a:ext cx="2057400" cy="5851525"/>
           </a:xfrm>
         </p:spPr>
         <p:txBody>
@@ -576,9 +561,10 @@
           <a:lstStyle/>
           <a:p>
             <a:r>
-              <a:rPr lang="en-US"/>
+              <a:rPr lang="en-US" smtClean="0"/>
               <a:t>Click to edit Master title style</a:t>
             </a:r>
+            <a:endParaRPr lang="en-US"/>
           </a:p>
         </p:txBody>
       </p:sp>
@@ -594,8 +580,8 @@
         </p:nvSpPr>
         <p:spPr>
           <a:xfrm>
-            <a:off x="457200" y="205979"/>
-            <a:ext cx="6019800" cy="4388644"/>
+            <a:off x="457200" y="274638"/>
+            <a:ext cx="6019800" cy="5851525"/>
           </a:xfrm>
         </p:spPr>
         <p:txBody>
@@ -604,37 +590,38 @@
           <a:p>
             <a:pPr lvl="0"/>
             <a:r>
-              <a:rPr lang="en-US"/>
+              <a:rPr lang="en-US" smtClean="0"/>
               <a:t>Click to edit Master text styles</a:t>
             </a:r>
           </a:p>
           <a:p>
             <a:pPr lvl="1"/>
             <a:r>
-              <a:rPr lang="en-US"/>
+              <a:rPr lang="en-US" smtClean="0"/>
               <a:t>Second level</a:t>
             </a:r>
           </a:p>
           <a:p>
             <a:pPr lvl="2"/>
             <a:r>
-              <a:rPr lang="en-US"/>
+              <a:rPr lang="en-US" smtClean="0"/>
               <a:t>Third level</a:t>
             </a:r>
           </a:p>
           <a:p>
             <a:pPr lvl="3"/>
             <a:r>
-              <a:rPr lang="en-US"/>
+              <a:rPr lang="en-US" smtClean="0"/>
               <a:t>Fourth level</a:t>
             </a:r>
           </a:p>
           <a:p>
             <a:pPr lvl="4"/>
             <a:r>
-              <a:rPr lang="en-US"/>
+              <a:rPr lang="en-US" smtClean="0"/>
               <a:t>Fifth level</a:t>
             </a:r>
+            <a:endParaRPr lang="en-US"/>
           </a:p>
         </p:txBody>
       </p:sp>
@@ -653,9 +640,9 @@
           <a:bodyPr/>
           <a:lstStyle/>
           <a:p>
-            <a:fld id="{241EB5C9-1307-BA42-ABA2-0BC069CD8E7F}" type="datetimeFigureOut">
-              <a:rPr lang="en-US" smtClean="0"/>
-              <a:t>1/2/22</a:t>
+            <a:fld id="{5BCAD085-E8A6-8845-BD4E-CB4CCA059FC4}" type="datetimeFigureOut">
+              <a:rPr lang="en-US" smtClean="0"/>
+              <a:t>1/27/13</a:t>
             </a:fld>
             <a:endParaRPr lang="en-US"/>
           </a:p>
@@ -695,7 +682,7 @@
           <a:bodyPr/>
           <a:lstStyle/>
           <a:p>
-            <a:fld id="{C5EF2332-01BF-834F-8236-50238282D533}" type="slidenum">
+            <a:fld id="{C1FF6DA9-008F-8B48-92A6-B652298478BF}" type="slidenum">
               <a:rPr lang="en-US" smtClean="0"/>
               <a:t>‹#›</a:t>
             </a:fld>
@@ -706,7 +693,7 @@
     </p:spTree>
     <p:extLst>
       <p:ext uri="{BB962C8B-B14F-4D97-AF65-F5344CB8AC3E}">
-        <p14:creationId xmlns:p14="http://schemas.microsoft.com/office/powerpoint/2010/main" val="2581529045"/>
+        <p14:creationId xmlns:p14="http://schemas.microsoft.com/office/powerpoint/2010/main" val="3612223792"/>
       </p:ext>
     </p:extLst>
   </p:cSld>
@@ -749,9 +736,10 @@
           <a:lstStyle/>
           <a:p>
             <a:r>
-              <a:rPr lang="en-US"/>
+              <a:rPr lang="en-US" smtClean="0"/>
               <a:t>Click to edit Master title style</a:t>
             </a:r>
+            <a:endParaRPr lang="en-US"/>
           </a:p>
         </p:txBody>
       </p:sp>
@@ -772,37 +760,38 @@
           <a:p>
             <a:pPr lvl="0"/>
             <a:r>
-              <a:rPr lang="en-US"/>
+              <a:rPr lang="en-US" smtClean="0"/>
               <a:t>Click to edit Master text styles</a:t>
             </a:r>
           </a:p>
           <a:p>
             <a:pPr lvl="1"/>
             <a:r>
-              <a:rPr lang="en-US"/>
+              <a:rPr lang="en-US" smtClean="0"/>
               <a:t>Second level</a:t>
             </a:r>
           </a:p>
           <a:p>
             <a:pPr lvl="2"/>
             <a:r>
-              <a:rPr lang="en-US"/>
+              <a:rPr lang="en-US" smtClean="0"/>
               <a:t>Third level</a:t>
             </a:r>
           </a:p>
           <a:p>
             <a:pPr lvl="3"/>
             <a:r>
-              <a:rPr lang="en-US"/>
+              <a:rPr lang="en-US" smtClean="0"/>
               <a:t>Fourth level</a:t>
             </a:r>
           </a:p>
           <a:p>
             <a:pPr lvl="4"/>
             <a:r>
-              <a:rPr lang="en-US"/>
+              <a:rPr lang="en-US" smtClean="0"/>
               <a:t>Fifth level</a:t>
             </a:r>
+            <a:endParaRPr lang="en-US"/>
           </a:p>
         </p:txBody>
       </p:sp>
@@ -821,9 +810,9 @@
           <a:bodyPr/>
           <a:lstStyle/>
           <a:p>
-            <a:fld id="{241EB5C9-1307-BA42-ABA2-0BC069CD8E7F}" type="datetimeFigureOut">
-              <a:rPr lang="en-US" smtClean="0"/>
-              <a:t>1/2/22</a:t>
+            <a:fld id="{5BCAD085-E8A6-8845-BD4E-CB4CCA059FC4}" type="datetimeFigureOut">
+              <a:rPr lang="en-US" smtClean="0"/>
+              <a:t>1/27/13</a:t>
             </a:fld>
             <a:endParaRPr lang="en-US"/>
           </a:p>
@@ -863,7 +852,7 @@
           <a:bodyPr/>
           <a:lstStyle/>
           <a:p>
-            <a:fld id="{C5EF2332-01BF-834F-8236-50238282D533}" type="slidenum">
+            <a:fld id="{C1FF6DA9-008F-8B48-92A6-B652298478BF}" type="slidenum">
               <a:rPr lang="en-US" smtClean="0"/>
               <a:t>‹#›</a:t>
             </a:fld>
@@ -874,7 +863,7 @@
     </p:spTree>
     <p:extLst>
       <p:ext uri="{BB962C8B-B14F-4D97-AF65-F5344CB8AC3E}">
-        <p14:creationId xmlns:p14="http://schemas.microsoft.com/office/powerpoint/2010/main" val="338346009"/>
+        <p14:creationId xmlns:p14="http://schemas.microsoft.com/office/powerpoint/2010/main" val="2614314258"/>
       </p:ext>
     </p:extLst>
   </p:cSld>
@@ -913,22 +902,23 @@
         </p:nvSpPr>
         <p:spPr>
           <a:xfrm>
-            <a:off x="722313" y="3305176"/>
-            <a:ext cx="7772400" cy="1021556"/>
+            <a:off x="722313" y="4406900"/>
+            <a:ext cx="7772400" cy="1362075"/>
           </a:xfrm>
         </p:spPr>
         <p:txBody>
           <a:bodyPr anchor="t"/>
           <a:lstStyle>
             <a:lvl1pPr algn="l">
-              <a:defRPr sz="3000" b="1" cap="all"/>
+              <a:defRPr sz="4000" b="1" cap="all"/>
             </a:lvl1pPr>
           </a:lstStyle>
           <a:p>
             <a:r>
-              <a:rPr lang="en-US"/>
+              <a:rPr lang="en-US" smtClean="0"/>
               <a:t>Click to edit Master title style</a:t>
             </a:r>
+            <a:endParaRPr lang="en-US"/>
           </a:p>
         </p:txBody>
       </p:sp>
@@ -944,8 +934,8 @@
         </p:nvSpPr>
         <p:spPr>
           <a:xfrm>
-            <a:off x="722313" y="2180035"/>
-            <a:ext cx="7772400" cy="1125140"/>
+            <a:off x="722313" y="2906713"/>
+            <a:ext cx="7772400" cy="1500187"/>
           </a:xfrm>
         </p:spPr>
         <p:txBody>
@@ -953,7 +943,7 @@
           <a:lstStyle>
             <a:lvl1pPr marL="0" indent="0">
               <a:buNone/>
-              <a:defRPr sz="1500">
+              <a:defRPr sz="2000">
                 <a:solidFill>
                   <a:schemeClr val="tx1">
                     <a:tint val="75000"/>
@@ -961,9 +951,9 @@
                 </a:solidFill>
               </a:defRPr>
             </a:lvl1pPr>
-            <a:lvl2pPr marL="342900" indent="0">
-              <a:buNone/>
-              <a:defRPr sz="1350">
+            <a:lvl2pPr marL="457200" indent="0">
+              <a:buNone/>
+              <a:defRPr sz="1800">
                 <a:solidFill>
                   <a:schemeClr val="tx1">
                     <a:tint val="75000"/>
@@ -971,9 +961,9 @@
                 </a:solidFill>
               </a:defRPr>
             </a:lvl2pPr>
-            <a:lvl3pPr marL="685800" indent="0">
-              <a:buNone/>
-              <a:defRPr sz="1200">
+            <a:lvl3pPr marL="914400" indent="0">
+              <a:buNone/>
+              <a:defRPr sz="1600">
                 <a:solidFill>
                   <a:schemeClr val="tx1">
                     <a:tint val="75000"/>
@@ -981,9 +971,9 @@
                 </a:solidFill>
               </a:defRPr>
             </a:lvl3pPr>
-            <a:lvl4pPr marL="1028700" indent="0">
-              <a:buNone/>
-              <a:defRPr sz="1050">
+            <a:lvl4pPr marL="1371600" indent="0">
+              <a:buNone/>
+              <a:defRPr sz="1400">
                 <a:solidFill>
                   <a:schemeClr val="tx1">
                     <a:tint val="75000"/>
@@ -991,9 +981,9 @@
                 </a:solidFill>
               </a:defRPr>
             </a:lvl4pPr>
-            <a:lvl5pPr marL="1371600" indent="0">
-              <a:buNone/>
-              <a:defRPr sz="1050">
+            <a:lvl5pPr marL="1828800" indent="0">
+              <a:buNone/>
+              <a:defRPr sz="1400">
                 <a:solidFill>
                   <a:schemeClr val="tx1">
                     <a:tint val="75000"/>
@@ -1001,9 +991,9 @@
                 </a:solidFill>
               </a:defRPr>
             </a:lvl5pPr>
-            <a:lvl6pPr marL="1714500" indent="0">
-              <a:buNone/>
-              <a:defRPr sz="1050">
+            <a:lvl6pPr marL="2286000" indent="0">
+              <a:buNone/>
+              <a:defRPr sz="1400">
                 <a:solidFill>
                   <a:schemeClr val="tx1">
                     <a:tint val="75000"/>
@@ -1011,9 +1001,9 @@
                 </a:solidFill>
               </a:defRPr>
             </a:lvl6pPr>
-            <a:lvl7pPr marL="2057400" indent="0">
-              <a:buNone/>
-              <a:defRPr sz="1050">
+            <a:lvl7pPr marL="2743200" indent="0">
+              <a:buNone/>
+              <a:defRPr sz="1400">
                 <a:solidFill>
                   <a:schemeClr val="tx1">
                     <a:tint val="75000"/>
@@ -1021,9 +1011,9 @@
                 </a:solidFill>
               </a:defRPr>
             </a:lvl7pPr>
-            <a:lvl8pPr marL="2400300" indent="0">
-              <a:buNone/>
-              <a:defRPr sz="1050">
+            <a:lvl8pPr marL="3200400" indent="0">
+              <a:buNone/>
+              <a:defRPr sz="1400">
                 <a:solidFill>
                   <a:schemeClr val="tx1">
                     <a:tint val="75000"/>
@@ -1031,9 +1021,9 @@
                 </a:solidFill>
               </a:defRPr>
             </a:lvl8pPr>
-            <a:lvl9pPr marL="2743200" indent="0">
-              <a:buNone/>
-              <a:defRPr sz="1050">
+            <a:lvl9pPr marL="3657600" indent="0">
+              <a:buNone/>
+              <a:defRPr sz="1400">
                 <a:solidFill>
                   <a:schemeClr val="tx1">
                     <a:tint val="75000"/>
@@ -1045,7 +1035,7 @@
           <a:p>
             <a:pPr lvl="0"/>
             <a:r>
-              <a:rPr lang="en-US"/>
+              <a:rPr lang="en-US" smtClean="0"/>
               <a:t>Click to edit Master text styles</a:t>
             </a:r>
           </a:p>
@@ -1066,9 +1056,9 @@
           <a:bodyPr/>
           <a:lstStyle/>
           <a:p>
-            <a:fld id="{241EB5C9-1307-BA42-ABA2-0BC069CD8E7F}" type="datetimeFigureOut">
-              <a:rPr lang="en-US" smtClean="0"/>
-              <a:t>1/2/22</a:t>
+            <a:fld id="{5BCAD085-E8A6-8845-BD4E-CB4CCA059FC4}" type="datetimeFigureOut">
+              <a:rPr lang="en-US" smtClean="0"/>
+              <a:t>1/27/13</a:t>
             </a:fld>
             <a:endParaRPr lang="en-US"/>
           </a:p>
@@ -1108,7 +1098,7 @@
           <a:bodyPr/>
           <a:lstStyle/>
           <a:p>
-            <a:fld id="{C5EF2332-01BF-834F-8236-50238282D533}" type="slidenum">
+            <a:fld id="{C1FF6DA9-008F-8B48-92A6-B652298478BF}" type="slidenum">
               <a:rPr lang="en-US" smtClean="0"/>
               <a:t>‹#›</a:t>
             </a:fld>
@@ -1119,7 +1109,7 @@
     </p:spTree>
     <p:extLst>
       <p:ext uri="{BB962C8B-B14F-4D97-AF65-F5344CB8AC3E}">
-        <p14:creationId xmlns:p14="http://schemas.microsoft.com/office/powerpoint/2010/main" val="1073069076"/>
+        <p14:creationId xmlns:p14="http://schemas.microsoft.com/office/powerpoint/2010/main" val="960648375"/>
       </p:ext>
     </p:extLst>
   </p:cSld>
@@ -1162,9 +1152,10 @@
           <a:lstStyle/>
           <a:p>
             <a:r>
-              <a:rPr lang="en-US"/>
+              <a:rPr lang="en-US" smtClean="0"/>
               <a:t>Click to edit Master title style</a:t>
             </a:r>
+            <a:endParaRPr lang="en-US"/>
           </a:p>
         </p:txBody>
       </p:sp>
@@ -1180,75 +1171,76 @@
         </p:nvSpPr>
         <p:spPr>
           <a:xfrm>
-            <a:off x="457200" y="1200151"/>
-            <a:ext cx="4038600" cy="3394472"/>
+            <a:off x="457200" y="1600200"/>
+            <a:ext cx="4038600" cy="4525963"/>
           </a:xfrm>
         </p:spPr>
         <p:txBody>
           <a:bodyPr/>
           <a:lstStyle>
             <a:lvl1pPr>
-              <a:defRPr sz="2100"/>
+              <a:defRPr sz="2800"/>
             </a:lvl1pPr>
             <a:lvl2pPr>
-              <a:defRPr sz="1800"/>
+              <a:defRPr sz="2400"/>
             </a:lvl2pPr>
             <a:lvl3pPr>
-              <a:defRPr sz="1500"/>
+              <a:defRPr sz="2000"/>
             </a:lvl3pPr>
             <a:lvl4pPr>
-              <a:defRPr sz="1350"/>
+              <a:defRPr sz="1800"/>
             </a:lvl4pPr>
             <a:lvl5pPr>
-              <a:defRPr sz="1350"/>
+              <a:defRPr sz="1800"/>
             </a:lvl5pPr>
             <a:lvl6pPr>
-              <a:defRPr sz="1350"/>
+              <a:defRPr sz="1800"/>
             </a:lvl6pPr>
             <a:lvl7pPr>
-              <a:defRPr sz="1350"/>
+              <a:defRPr sz="1800"/>
             </a:lvl7pPr>
             <a:lvl8pPr>
-              <a:defRPr sz="1350"/>
+              <a:defRPr sz="1800"/>
             </a:lvl8pPr>
             <a:lvl9pPr>
-              <a:defRPr sz="1350"/>
+              <a:defRPr sz="1800"/>
             </a:lvl9pPr>
           </a:lstStyle>
           <a:p>
             <a:pPr lvl="0"/>
             <a:r>
-              <a:rPr lang="en-US"/>
+              <a:rPr lang="en-US" smtClean="0"/>
               <a:t>Click to edit Master text styles</a:t>
             </a:r>
           </a:p>
           <a:p>
             <a:pPr lvl="1"/>
             <a:r>
-              <a:rPr lang="en-US"/>
+              <a:rPr lang="en-US" smtClean="0"/>
               <a:t>Second level</a:t>
             </a:r>
           </a:p>
           <a:p>
             <a:pPr lvl="2"/>
             <a:r>
-              <a:rPr lang="en-US"/>
+              <a:rPr lang="en-US" smtClean="0"/>
               <a:t>Third level</a:t>
             </a:r>
           </a:p>
           <a:p>
             <a:pPr lvl="3"/>
             <a:r>
-              <a:rPr lang="en-US"/>
+              <a:rPr lang="en-US" smtClean="0"/>
               <a:t>Fourth level</a:t>
             </a:r>
           </a:p>
           <a:p>
             <a:pPr lvl="4"/>
             <a:r>
-              <a:rPr lang="en-US"/>
+              <a:rPr lang="en-US" smtClean="0"/>
               <a:t>Fifth level</a:t>
             </a:r>
+            <a:endParaRPr lang="en-US"/>
           </a:p>
         </p:txBody>
       </p:sp>
@@ -1264,75 +1256,76 @@
         </p:nvSpPr>
         <p:spPr>
           <a:xfrm>
-            <a:off x="4648200" y="1200151"/>
-            <a:ext cx="4038600" cy="3394472"/>
+            <a:off x="4648200" y="1600200"/>
+            <a:ext cx="4038600" cy="4525963"/>
           </a:xfrm>
         </p:spPr>
         <p:txBody>
           <a:bodyPr/>
           <a:lstStyle>
             <a:lvl1pPr>
-              <a:defRPr sz="2100"/>
+              <a:defRPr sz="2800"/>
             </a:lvl1pPr>
             <a:lvl2pPr>
-              <a:defRPr sz="1800"/>
+              <a:defRPr sz="2400"/>
             </a:lvl2pPr>
             <a:lvl3pPr>
-              <a:defRPr sz="1500"/>
+              <a:defRPr sz="2000"/>
             </a:lvl3pPr>
             <a:lvl4pPr>
-              <a:defRPr sz="1350"/>
+              <a:defRPr sz="1800"/>
             </a:lvl4pPr>
             <a:lvl5pPr>
-              <a:defRPr sz="1350"/>
+              <a:defRPr sz="1800"/>
             </a:lvl5pPr>
             <a:lvl6pPr>
-              <a:defRPr sz="1350"/>
+              <a:defRPr sz="1800"/>
             </a:lvl6pPr>
             <a:lvl7pPr>
-              <a:defRPr sz="1350"/>
+              <a:defRPr sz="1800"/>
             </a:lvl7pPr>
             <a:lvl8pPr>
-              <a:defRPr sz="1350"/>
+              <a:defRPr sz="1800"/>
             </a:lvl8pPr>
             <a:lvl9pPr>
-              <a:defRPr sz="1350"/>
+              <a:defRPr sz="1800"/>
             </a:lvl9pPr>
           </a:lstStyle>
           <a:p>
             <a:pPr lvl="0"/>
             <a:r>
-              <a:rPr lang="en-US"/>
+              <a:rPr lang="en-US" smtClean="0"/>
               <a:t>Click to edit Master text styles</a:t>
             </a:r>
           </a:p>
           <a:p>
             <a:pPr lvl="1"/>
             <a:r>
-              <a:rPr lang="en-US"/>
+              <a:rPr lang="en-US" smtClean="0"/>
               <a:t>Second level</a:t>
             </a:r>
           </a:p>
           <a:p>
             <a:pPr lvl="2"/>
             <a:r>
-              <a:rPr lang="en-US"/>
+              <a:rPr lang="en-US" smtClean="0"/>
               <a:t>Third level</a:t>
             </a:r>
           </a:p>
           <a:p>
             <a:pPr lvl="3"/>
             <a:r>
-              <a:rPr lang="en-US"/>
+              <a:rPr lang="en-US" smtClean="0"/>
               <a:t>Fourth level</a:t>
             </a:r>
           </a:p>
           <a:p>
             <a:pPr lvl="4"/>
             <a:r>
-              <a:rPr lang="en-US"/>
+              <a:rPr lang="en-US" smtClean="0"/>
               <a:t>Fifth level</a:t>
             </a:r>
+            <a:endParaRPr lang="en-US"/>
           </a:p>
         </p:txBody>
       </p:sp>
@@ -1351,9 +1344,9 @@
           <a:bodyPr/>
           <a:lstStyle/>
           <a:p>
-            <a:fld id="{241EB5C9-1307-BA42-ABA2-0BC069CD8E7F}" type="datetimeFigureOut">
-              <a:rPr lang="en-US" smtClean="0"/>
-              <a:t>1/2/22</a:t>
+            <a:fld id="{5BCAD085-E8A6-8845-BD4E-CB4CCA059FC4}" type="datetimeFigureOut">
+              <a:rPr lang="en-US" smtClean="0"/>
+              <a:t>1/27/13</a:t>
             </a:fld>
             <a:endParaRPr lang="en-US"/>
           </a:p>
@@ -1393,7 +1386,7 @@
           <a:bodyPr/>
           <a:lstStyle/>
           <a:p>
-            <a:fld id="{C5EF2332-01BF-834F-8236-50238282D533}" type="slidenum">
+            <a:fld id="{C1FF6DA9-008F-8B48-92A6-B652298478BF}" type="slidenum">
               <a:rPr lang="en-US" smtClean="0"/>
               <a:t>‹#›</a:t>
             </a:fld>
@@ -1404,7 +1397,7 @@
     </p:spTree>
     <p:extLst>
       <p:ext uri="{BB962C8B-B14F-4D97-AF65-F5344CB8AC3E}">
-        <p14:creationId xmlns:p14="http://schemas.microsoft.com/office/powerpoint/2010/main" val="2619886245"/>
+        <p14:creationId xmlns:p14="http://schemas.microsoft.com/office/powerpoint/2010/main" val="2782244947"/>
       </p:ext>
     </p:extLst>
   </p:cSld>
@@ -1451,9 +1444,10 @@
           </a:lstStyle>
           <a:p>
             <a:r>
-              <a:rPr lang="en-US"/>
+              <a:rPr lang="en-US" smtClean="0"/>
               <a:t>Click to edit Master title style</a:t>
             </a:r>
+            <a:endParaRPr lang="en-US"/>
           </a:p>
         </p:txBody>
       </p:sp>
@@ -1469,8 +1463,8 @@
         </p:nvSpPr>
         <p:spPr>
           <a:xfrm>
-            <a:off x="457200" y="1151335"/>
-            <a:ext cx="4040188" cy="479822"/>
+            <a:off x="457200" y="1535113"/>
+            <a:ext cx="4040188" cy="639762"/>
           </a:xfrm>
         </p:spPr>
         <p:txBody>
@@ -1478,45 +1472,45 @@
           <a:lstStyle>
             <a:lvl1pPr marL="0" indent="0">
               <a:buNone/>
+              <a:defRPr sz="2400" b="1"/>
+            </a:lvl1pPr>
+            <a:lvl2pPr marL="457200" indent="0">
+              <a:buNone/>
+              <a:defRPr sz="2000" b="1"/>
+            </a:lvl2pPr>
+            <a:lvl3pPr marL="914400" indent="0">
+              <a:buNone/>
               <a:defRPr sz="1800" b="1"/>
-            </a:lvl1pPr>
-            <a:lvl2pPr marL="342900" indent="0">
-              <a:buNone/>
-              <a:defRPr sz="1500" b="1"/>
-            </a:lvl2pPr>
-            <a:lvl3pPr marL="685800" indent="0">
-              <a:buNone/>
-              <a:defRPr sz="1350" b="1"/>
             </a:lvl3pPr>
-            <a:lvl4pPr marL="1028700" indent="0">
-              <a:buNone/>
-              <a:defRPr sz="1200" b="1"/>
+            <a:lvl4pPr marL="1371600" indent="0">
+              <a:buNone/>
+              <a:defRPr sz="1600" b="1"/>
             </a:lvl4pPr>
-            <a:lvl5pPr marL="1371600" indent="0">
-              <a:buNone/>
-              <a:defRPr sz="1200" b="1"/>
+            <a:lvl5pPr marL="1828800" indent="0">
+              <a:buNone/>
+              <a:defRPr sz="1600" b="1"/>
             </a:lvl5pPr>
-            <a:lvl6pPr marL="1714500" indent="0">
-              <a:buNone/>
-              <a:defRPr sz="1200" b="1"/>
+            <a:lvl6pPr marL="2286000" indent="0">
+              <a:buNone/>
+              <a:defRPr sz="1600" b="1"/>
             </a:lvl6pPr>
-            <a:lvl7pPr marL="2057400" indent="0">
-              <a:buNone/>
-              <a:defRPr sz="1200" b="1"/>
+            <a:lvl7pPr marL="2743200" indent="0">
+              <a:buNone/>
+              <a:defRPr sz="1600" b="1"/>
             </a:lvl7pPr>
-            <a:lvl8pPr marL="2400300" indent="0">
-              <a:buNone/>
-              <a:defRPr sz="1200" b="1"/>
+            <a:lvl8pPr marL="3200400" indent="0">
+              <a:buNone/>
+              <a:defRPr sz="1600" b="1"/>
             </a:lvl8pPr>
-            <a:lvl9pPr marL="2743200" indent="0">
-              <a:buNone/>
-              <a:defRPr sz="1200" b="1"/>
+            <a:lvl9pPr marL="3657600" indent="0">
+              <a:buNone/>
+              <a:defRPr sz="1600" b="1"/>
             </a:lvl9pPr>
           </a:lstStyle>
           <a:p>
             <a:pPr lvl="0"/>
             <a:r>
-              <a:rPr lang="en-US"/>
+              <a:rPr lang="en-US" smtClean="0"/>
               <a:t>Click to edit Master text styles</a:t>
             </a:r>
           </a:p>
@@ -1534,75 +1528,76 @@
         </p:nvSpPr>
         <p:spPr>
           <a:xfrm>
-            <a:off x="457200" y="1631156"/>
-            <a:ext cx="4040188" cy="2963466"/>
+            <a:off x="457200" y="2174875"/>
+            <a:ext cx="4040188" cy="3951288"/>
           </a:xfrm>
         </p:spPr>
         <p:txBody>
           <a:bodyPr/>
           <a:lstStyle>
             <a:lvl1pPr>
-              <a:defRPr sz="1800"/>
+              <a:defRPr sz="2400"/>
             </a:lvl1pPr>
             <a:lvl2pPr>
-              <a:defRPr sz="1500"/>
+              <a:defRPr sz="2000"/>
             </a:lvl2pPr>
             <a:lvl3pPr>
-              <a:defRPr sz="1350"/>
+              <a:defRPr sz="1800"/>
             </a:lvl3pPr>
             <a:lvl4pPr>
-              <a:defRPr sz="1200"/>
+              <a:defRPr sz="1600"/>
             </a:lvl4pPr>
             <a:lvl5pPr>
-              <a:defRPr sz="1200"/>
+              <a:defRPr sz="1600"/>
             </a:lvl5pPr>
             <a:lvl6pPr>
-              <a:defRPr sz="1200"/>
+              <a:defRPr sz="1600"/>
             </a:lvl6pPr>
             <a:lvl7pPr>
-              <a:defRPr sz="1200"/>
+              <a:defRPr sz="1600"/>
             </a:lvl7pPr>
             <a:lvl8pPr>
-              <a:defRPr sz="1200"/>
+              <a:defRPr sz="1600"/>
             </a:lvl8pPr>
             <a:lvl9pPr>
-              <a:defRPr sz="1200"/>
+              <a:defRPr sz="1600"/>
             </a:lvl9pPr>
           </a:lstStyle>
           <a:p>
             <a:pPr lvl="0"/>
             <a:r>
-              <a:rPr lang="en-US"/>
+              <a:rPr lang="en-US" smtClean="0"/>
               <a:t>Click to edit Master text styles</a:t>
             </a:r>
           </a:p>
           <a:p>
             <a:pPr lvl="1"/>
             <a:r>
-              <a:rPr lang="en-US"/>
+              <a:rPr lang="en-US" smtClean="0"/>
               <a:t>Second level</a:t>
             </a:r>
           </a:p>
           <a:p>
             <a:pPr lvl="2"/>
             <a:r>
-              <a:rPr lang="en-US"/>
+              <a:rPr lang="en-US" smtClean="0"/>
               <a:t>Third level</a:t>
             </a:r>
           </a:p>
           <a:p>
             <a:pPr lvl="3"/>
             <a:r>
-              <a:rPr lang="en-US"/>
+              <a:rPr lang="en-US" smtClean="0"/>
               <a:t>Fourth level</a:t>
             </a:r>
           </a:p>
           <a:p>
             <a:pPr lvl="4"/>
             <a:r>
-              <a:rPr lang="en-US"/>
+              <a:rPr lang="en-US" smtClean="0"/>
               <a:t>Fifth level</a:t>
             </a:r>
+            <a:endParaRPr lang="en-US"/>
           </a:p>
         </p:txBody>
       </p:sp>
@@ -1618,8 +1613,8 @@
         </p:nvSpPr>
         <p:spPr>
           <a:xfrm>
-            <a:off x="4645026" y="1151335"/>
-            <a:ext cx="4041775" cy="479822"/>
+            <a:off x="4645025" y="1535113"/>
+            <a:ext cx="4041775" cy="639762"/>
           </a:xfrm>
         </p:spPr>
         <p:txBody>
@@ -1627,45 +1622,45 @@
           <a:lstStyle>
             <a:lvl1pPr marL="0" indent="0">
               <a:buNone/>
+              <a:defRPr sz="2400" b="1"/>
+            </a:lvl1pPr>
+            <a:lvl2pPr marL="457200" indent="0">
+              <a:buNone/>
+              <a:defRPr sz="2000" b="1"/>
+            </a:lvl2pPr>
+            <a:lvl3pPr marL="914400" indent="0">
+              <a:buNone/>
               <a:defRPr sz="1800" b="1"/>
-            </a:lvl1pPr>
-            <a:lvl2pPr marL="342900" indent="0">
-              <a:buNone/>
-              <a:defRPr sz="1500" b="1"/>
-            </a:lvl2pPr>
-            <a:lvl3pPr marL="685800" indent="0">
-              <a:buNone/>
-              <a:defRPr sz="1350" b="1"/>
             </a:lvl3pPr>
-            <a:lvl4pPr marL="1028700" indent="0">
-              <a:buNone/>
-              <a:defRPr sz="1200" b="1"/>
+            <a:lvl4pPr marL="1371600" indent="0">
+              <a:buNone/>
+              <a:defRPr sz="1600" b="1"/>
             </a:lvl4pPr>
-            <a:lvl5pPr marL="1371600" indent="0">
-              <a:buNone/>
-              <a:defRPr sz="1200" b="1"/>
+            <a:lvl5pPr marL="1828800" indent="0">
+              <a:buNone/>
+              <a:defRPr sz="1600" b="1"/>
             </a:lvl5pPr>
-            <a:lvl6pPr marL="1714500" indent="0">
-              <a:buNone/>
-              <a:defRPr sz="1200" b="1"/>
+            <a:lvl6pPr marL="2286000" indent="0">
+              <a:buNone/>
+              <a:defRPr sz="1600" b="1"/>
             </a:lvl6pPr>
-            <a:lvl7pPr marL="2057400" indent="0">
-              <a:buNone/>
-              <a:defRPr sz="1200" b="1"/>
+            <a:lvl7pPr marL="2743200" indent="0">
+              <a:buNone/>
+              <a:defRPr sz="1600" b="1"/>
             </a:lvl7pPr>
-            <a:lvl8pPr marL="2400300" indent="0">
-              <a:buNone/>
-              <a:defRPr sz="1200" b="1"/>
+            <a:lvl8pPr marL="3200400" indent="0">
+              <a:buNone/>
+              <a:defRPr sz="1600" b="1"/>
             </a:lvl8pPr>
-            <a:lvl9pPr marL="2743200" indent="0">
-              <a:buNone/>
-              <a:defRPr sz="1200" b="1"/>
+            <a:lvl9pPr marL="3657600" indent="0">
+              <a:buNone/>
+              <a:defRPr sz="1600" b="1"/>
             </a:lvl9pPr>
           </a:lstStyle>
           <a:p>
             <a:pPr lvl="0"/>
             <a:r>
-              <a:rPr lang="en-US"/>
+              <a:rPr lang="en-US" smtClean="0"/>
               <a:t>Click to edit Master text styles</a:t>
             </a:r>
           </a:p>
@@ -1683,75 +1678,76 @@
         </p:nvSpPr>
         <p:spPr>
           <a:xfrm>
-            <a:off x="4645026" y="1631156"/>
-            <a:ext cx="4041775" cy="2963466"/>
+            <a:off x="4645025" y="2174875"/>
+            <a:ext cx="4041775" cy="3951288"/>
           </a:xfrm>
         </p:spPr>
         <p:txBody>
           <a:bodyPr/>
           <a:lstStyle>
             <a:lvl1pPr>
-              <a:defRPr sz="1800"/>
+              <a:defRPr sz="2400"/>
             </a:lvl1pPr>
             <a:lvl2pPr>
-              <a:defRPr sz="1500"/>
+              <a:defRPr sz="2000"/>
             </a:lvl2pPr>
             <a:lvl3pPr>
-              <a:defRPr sz="1350"/>
+              <a:defRPr sz="1800"/>
             </a:lvl3pPr>
             <a:lvl4pPr>
-              <a:defRPr sz="1200"/>
+              <a:defRPr sz="1600"/>
             </a:lvl4pPr>
             <a:lvl5pPr>
-              <a:defRPr sz="1200"/>
+              <a:defRPr sz="1600"/>
             </a:lvl5pPr>
             <a:lvl6pPr>
-              <a:defRPr sz="1200"/>
+              <a:defRPr sz="1600"/>
             </a:lvl6pPr>
             <a:lvl7pPr>
-              <a:defRPr sz="1200"/>
+              <a:defRPr sz="1600"/>
             </a:lvl7pPr>
             <a:lvl8pPr>
-              <a:defRPr sz="1200"/>
+              <a:defRPr sz="1600"/>
             </a:lvl8pPr>
             <a:lvl9pPr>
-              <a:defRPr sz="1200"/>
+              <a:defRPr sz="1600"/>
             </a:lvl9pPr>
           </a:lstStyle>
           <a:p>
             <a:pPr lvl="0"/>
             <a:r>
-              <a:rPr lang="en-US"/>
+              <a:rPr lang="en-US" smtClean="0"/>
               <a:t>Click to edit Master text styles</a:t>
             </a:r>
           </a:p>
           <a:p>
             <a:pPr lvl="1"/>
             <a:r>
-              <a:rPr lang="en-US"/>
+              <a:rPr lang="en-US" smtClean="0"/>
               <a:t>Second level</a:t>
             </a:r>
           </a:p>
           <a:p>
             <a:pPr lvl="2"/>
             <a:r>
-              <a:rPr lang="en-US"/>
+              <a:rPr lang="en-US" smtClean="0"/>
               <a:t>Third level</a:t>
             </a:r>
           </a:p>
           <a:p>
             <a:pPr lvl="3"/>
             <a:r>
-              <a:rPr lang="en-US"/>
+              <a:rPr lang="en-US" smtClean="0"/>
               <a:t>Fourth level</a:t>
             </a:r>
           </a:p>
           <a:p>
             <a:pPr lvl="4"/>
             <a:r>
-              <a:rPr lang="en-US"/>
+              <a:rPr lang="en-US" smtClean="0"/>
               <a:t>Fifth level</a:t>
             </a:r>
+            <a:endParaRPr lang="en-US"/>
           </a:p>
         </p:txBody>
       </p:sp>
@@ -1770,9 +1766,9 @@
           <a:bodyPr/>
           <a:lstStyle/>
           <a:p>
-            <a:fld id="{241EB5C9-1307-BA42-ABA2-0BC069CD8E7F}" type="datetimeFigureOut">
-              <a:rPr lang="en-US" smtClean="0"/>
-              <a:t>1/2/22</a:t>
+            <a:fld id="{5BCAD085-E8A6-8845-BD4E-CB4CCA059FC4}" type="datetimeFigureOut">
+              <a:rPr lang="en-US" smtClean="0"/>
+              <a:t>1/27/13</a:t>
             </a:fld>
             <a:endParaRPr lang="en-US"/>
           </a:p>
@@ -1812,7 +1808,7 @@
           <a:bodyPr/>
           <a:lstStyle/>
           <a:p>
-            <a:fld id="{C5EF2332-01BF-834F-8236-50238282D533}" type="slidenum">
+            <a:fld id="{C1FF6DA9-008F-8B48-92A6-B652298478BF}" type="slidenum">
               <a:rPr lang="en-US" smtClean="0"/>
               <a:t>‹#›</a:t>
             </a:fld>
@@ -1823,7 +1819,7 @@
     </p:spTree>
     <p:extLst>
       <p:ext uri="{BB962C8B-B14F-4D97-AF65-F5344CB8AC3E}">
-        <p14:creationId xmlns:p14="http://schemas.microsoft.com/office/powerpoint/2010/main" val="2535793967"/>
+        <p14:creationId xmlns:p14="http://schemas.microsoft.com/office/powerpoint/2010/main" val="990158736"/>
       </p:ext>
     </p:extLst>
   </p:cSld>
@@ -1866,9 +1862,10 @@
           <a:lstStyle/>
           <a:p>
             <a:r>
-              <a:rPr lang="en-US"/>
+              <a:rPr lang="en-US" smtClean="0"/>
               <a:t>Click to edit Master title style</a:t>
             </a:r>
+            <a:endParaRPr lang="en-US"/>
           </a:p>
         </p:txBody>
       </p:sp>
@@ -1887,9 +1884,9 @@
           <a:bodyPr/>
           <a:lstStyle/>
           <a:p>
-            <a:fld id="{241EB5C9-1307-BA42-ABA2-0BC069CD8E7F}" type="datetimeFigureOut">
-              <a:rPr lang="en-US" smtClean="0"/>
-              <a:t>1/2/22</a:t>
+            <a:fld id="{5BCAD085-E8A6-8845-BD4E-CB4CCA059FC4}" type="datetimeFigureOut">
+              <a:rPr lang="en-US" smtClean="0"/>
+              <a:t>1/27/13</a:t>
             </a:fld>
             <a:endParaRPr lang="en-US"/>
           </a:p>
@@ -1929,7 +1926,7 @@
           <a:bodyPr/>
           <a:lstStyle/>
           <a:p>
-            <a:fld id="{C5EF2332-01BF-834F-8236-50238282D533}" type="slidenum">
+            <a:fld id="{C1FF6DA9-008F-8B48-92A6-B652298478BF}" type="slidenum">
               <a:rPr lang="en-US" smtClean="0"/>
               <a:t>‹#›</a:t>
             </a:fld>
@@ -1940,7 +1937,7 @@
     </p:spTree>
     <p:extLst>
       <p:ext uri="{BB962C8B-B14F-4D97-AF65-F5344CB8AC3E}">
-        <p14:creationId xmlns:p14="http://schemas.microsoft.com/office/powerpoint/2010/main" val="3472721253"/>
+        <p14:creationId xmlns:p14="http://schemas.microsoft.com/office/powerpoint/2010/main" val="727027711"/>
       </p:ext>
     </p:extLst>
   </p:cSld>
@@ -1982,9 +1979,9 @@
           <a:bodyPr/>
           <a:lstStyle/>
           <a:p>
-            <a:fld id="{241EB5C9-1307-BA42-ABA2-0BC069CD8E7F}" type="datetimeFigureOut">
-              <a:rPr lang="en-US" smtClean="0"/>
-              <a:t>1/2/22</a:t>
+            <a:fld id="{5BCAD085-E8A6-8845-BD4E-CB4CCA059FC4}" type="datetimeFigureOut">
+              <a:rPr lang="en-US" smtClean="0"/>
+              <a:t>1/27/13</a:t>
             </a:fld>
             <a:endParaRPr lang="en-US"/>
           </a:p>
@@ -2024,7 +2021,7 @@
           <a:bodyPr/>
           <a:lstStyle/>
           <a:p>
-            <a:fld id="{C5EF2332-01BF-834F-8236-50238282D533}" type="slidenum">
+            <a:fld id="{C1FF6DA9-008F-8B48-92A6-B652298478BF}" type="slidenum">
               <a:rPr lang="en-US" smtClean="0"/>
               <a:t>‹#›</a:t>
             </a:fld>
@@ -2035,7 +2032,7 @@
     </p:spTree>
     <p:extLst>
       <p:ext uri="{BB962C8B-B14F-4D97-AF65-F5344CB8AC3E}">
-        <p14:creationId xmlns:p14="http://schemas.microsoft.com/office/powerpoint/2010/main" val="2130901097"/>
+        <p14:creationId xmlns:p14="http://schemas.microsoft.com/office/powerpoint/2010/main" val="1212999818"/>
       </p:ext>
     </p:extLst>
   </p:cSld>
@@ -2074,22 +2071,23 @@
         </p:nvSpPr>
         <p:spPr>
           <a:xfrm>
-            <a:off x="457201" y="204787"/>
-            <a:ext cx="3008313" cy="871538"/>
+            <a:off x="457200" y="273050"/>
+            <a:ext cx="3008313" cy="1162050"/>
           </a:xfrm>
         </p:spPr>
         <p:txBody>
           <a:bodyPr anchor="b"/>
           <a:lstStyle>
             <a:lvl1pPr algn="l">
-              <a:defRPr sz="1500" b="1"/>
+              <a:defRPr sz="2000" b="1"/>
             </a:lvl1pPr>
           </a:lstStyle>
           <a:p>
             <a:r>
-              <a:rPr lang="en-US"/>
+              <a:rPr lang="en-US" smtClean="0"/>
               <a:t>Click to edit Master title style</a:t>
             </a:r>
+            <a:endParaRPr lang="en-US"/>
           </a:p>
         </p:txBody>
       </p:sp>
@@ -2105,75 +2103,76 @@
         </p:nvSpPr>
         <p:spPr>
           <a:xfrm>
-            <a:off x="3575050" y="204788"/>
-            <a:ext cx="5111750" cy="4389835"/>
+            <a:off x="3575050" y="273050"/>
+            <a:ext cx="5111750" cy="5853113"/>
           </a:xfrm>
         </p:spPr>
         <p:txBody>
           <a:bodyPr/>
           <a:lstStyle>
             <a:lvl1pPr>
-              <a:defRPr sz="2400"/>
+              <a:defRPr sz="3200"/>
             </a:lvl1pPr>
             <a:lvl2pPr>
-              <a:defRPr sz="2100"/>
+              <a:defRPr sz="2800"/>
             </a:lvl2pPr>
             <a:lvl3pPr>
-              <a:defRPr sz="1800"/>
+              <a:defRPr sz="2400"/>
             </a:lvl3pPr>
             <a:lvl4pPr>
-              <a:defRPr sz="1500"/>
+              <a:defRPr sz="2000"/>
             </a:lvl4pPr>
             <a:lvl5pPr>
-              <a:defRPr sz="1500"/>
+              <a:defRPr sz="2000"/>
             </a:lvl5pPr>
             <a:lvl6pPr>
-              <a:defRPr sz="1500"/>
+              <a:defRPr sz="2000"/>
             </a:lvl6pPr>
             <a:lvl7pPr>
-              <a:defRPr sz="1500"/>
+              <a:defRPr sz="2000"/>
             </a:lvl7pPr>
             <a:lvl8pPr>
-              <a:defRPr sz="1500"/>
+              <a:defRPr sz="2000"/>
             </a:lvl8pPr>
             <a:lvl9pPr>
-              <a:defRPr sz="1500"/>
+              <a:defRPr sz="2000"/>
             </a:lvl9pPr>
           </a:lstStyle>
           <a:p>
             <a:pPr lvl="0"/>
             <a:r>
-              <a:rPr lang="en-US"/>
+              <a:rPr lang="en-US" smtClean="0"/>
               <a:t>Click to edit Master text styles</a:t>
             </a:r>
           </a:p>
           <a:p>
             <a:pPr lvl="1"/>
             <a:r>
-              <a:rPr lang="en-US"/>
+              <a:rPr lang="en-US" smtClean="0"/>
               <a:t>Second level</a:t>
             </a:r>
           </a:p>
           <a:p>
             <a:pPr lvl="2"/>
             <a:r>
-              <a:rPr lang="en-US"/>
+              <a:rPr lang="en-US" smtClean="0"/>
               <a:t>Third level</a:t>
             </a:r>
           </a:p>
           <a:p>
             <a:pPr lvl="3"/>
             <a:r>
-              <a:rPr lang="en-US"/>
+              <a:rPr lang="en-US" smtClean="0"/>
               <a:t>Fourth level</a:t>
             </a:r>
           </a:p>
           <a:p>
             <a:pPr lvl="4"/>
             <a:r>
-              <a:rPr lang="en-US"/>
+              <a:rPr lang="en-US" smtClean="0"/>
               <a:t>Fifth level</a:t>
             </a:r>
+            <a:endParaRPr lang="en-US"/>
           </a:p>
         </p:txBody>
       </p:sp>
@@ -2189,8 +2188,8 @@
         </p:nvSpPr>
         <p:spPr>
           <a:xfrm>
-            <a:off x="457201" y="1076326"/>
-            <a:ext cx="3008313" cy="3518297"/>
+            <a:off x="457200" y="1435100"/>
+            <a:ext cx="3008313" cy="4691063"/>
           </a:xfrm>
         </p:spPr>
         <p:txBody>
@@ -2198,45 +2197,45 @@
           <a:lstStyle>
             <a:lvl1pPr marL="0" indent="0">
               <a:buNone/>
-              <a:defRPr sz="1050"/>
+              <a:defRPr sz="1400"/>
             </a:lvl1pPr>
-            <a:lvl2pPr marL="342900" indent="0">
+            <a:lvl2pPr marL="457200" indent="0">
+              <a:buNone/>
+              <a:defRPr sz="1200"/>
+            </a:lvl2pPr>
+            <a:lvl3pPr marL="914400" indent="0">
+              <a:buNone/>
+              <a:defRPr sz="1000"/>
+            </a:lvl3pPr>
+            <a:lvl4pPr marL="1371600" indent="0">
               <a:buNone/>
               <a:defRPr sz="900"/>
-            </a:lvl2pPr>
-            <a:lvl3pPr marL="685800" indent="0">
-              <a:buNone/>
-              <a:defRPr sz="750"/>
-            </a:lvl3pPr>
-            <a:lvl4pPr marL="1028700" indent="0">
-              <a:buNone/>
-              <a:defRPr sz="675"/>
             </a:lvl4pPr>
-            <a:lvl5pPr marL="1371600" indent="0">
-              <a:buNone/>
-              <a:defRPr sz="675"/>
+            <a:lvl5pPr marL="1828800" indent="0">
+              <a:buNone/>
+              <a:defRPr sz="900"/>
             </a:lvl5pPr>
-            <a:lvl6pPr marL="1714500" indent="0">
-              <a:buNone/>
-              <a:defRPr sz="675"/>
+            <a:lvl6pPr marL="2286000" indent="0">
+              <a:buNone/>
+              <a:defRPr sz="900"/>
             </a:lvl6pPr>
-            <a:lvl7pPr marL="2057400" indent="0">
-              <a:buNone/>
-              <a:defRPr sz="675"/>
+            <a:lvl7pPr marL="2743200" indent="0">
+              <a:buNone/>
+              <a:defRPr sz="900"/>
             </a:lvl7pPr>
-            <a:lvl8pPr marL="2400300" indent="0">
-              <a:buNone/>
-              <a:defRPr sz="675"/>
+            <a:lvl8pPr marL="3200400" indent="0">
+              <a:buNone/>
+              <a:defRPr sz="900"/>
             </a:lvl8pPr>
-            <a:lvl9pPr marL="2743200" indent="0">
-              <a:buNone/>
-              <a:defRPr sz="675"/>
+            <a:lvl9pPr marL="3657600" indent="0">
+              <a:buNone/>
+              <a:defRPr sz="900"/>
             </a:lvl9pPr>
           </a:lstStyle>
           <a:p>
             <a:pPr lvl="0"/>
             <a:r>
-              <a:rPr lang="en-US"/>
+              <a:rPr lang="en-US" smtClean="0"/>
               <a:t>Click to edit Master text styles</a:t>
             </a:r>
           </a:p>
@@ -2257,9 +2256,9 @@
           <a:bodyPr/>
           <a:lstStyle/>
           <a:p>
-            <a:fld id="{241EB5C9-1307-BA42-ABA2-0BC069CD8E7F}" type="datetimeFigureOut">
-              <a:rPr lang="en-US" smtClean="0"/>
-              <a:t>1/2/22</a:t>
+            <a:fld id="{5BCAD085-E8A6-8845-BD4E-CB4CCA059FC4}" type="datetimeFigureOut">
+              <a:rPr lang="en-US" smtClean="0"/>
+              <a:t>1/27/13</a:t>
             </a:fld>
             <a:endParaRPr lang="en-US"/>
           </a:p>
@@ -2299,7 +2298,7 @@
           <a:bodyPr/>
           <a:lstStyle/>
           <a:p>
-            <a:fld id="{C5EF2332-01BF-834F-8236-50238282D533}" type="slidenum">
+            <a:fld id="{C1FF6DA9-008F-8B48-92A6-B652298478BF}" type="slidenum">
               <a:rPr lang="en-US" smtClean="0"/>
               <a:t>‹#›</a:t>
             </a:fld>
@@ -2310,7 +2309,7 @@
     </p:spTree>
     <p:extLst>
       <p:ext uri="{BB962C8B-B14F-4D97-AF65-F5344CB8AC3E}">
-        <p14:creationId xmlns:p14="http://schemas.microsoft.com/office/powerpoint/2010/main" val="3540895647"/>
+        <p14:creationId xmlns:p14="http://schemas.microsoft.com/office/powerpoint/2010/main" val="1840726560"/>
       </p:ext>
     </p:extLst>
   </p:cSld>
@@ -2349,22 +2348,23 @@
         </p:nvSpPr>
         <p:spPr>
           <a:xfrm>
-            <a:off x="1792288" y="3600450"/>
-            <a:ext cx="5486400" cy="425054"/>
+            <a:off x="1792288" y="4800600"/>
+            <a:ext cx="5486400" cy="566738"/>
           </a:xfrm>
         </p:spPr>
         <p:txBody>
           <a:bodyPr anchor="b"/>
           <a:lstStyle>
             <a:lvl1pPr algn="l">
-              <a:defRPr sz="1500" b="1"/>
+              <a:defRPr sz="2000" b="1"/>
             </a:lvl1pPr>
           </a:lstStyle>
           <a:p>
             <a:r>
-              <a:rPr lang="en-US"/>
+              <a:rPr lang="en-US" smtClean="0"/>
               <a:t>Click to edit Master title style</a:t>
             </a:r>
+            <a:endParaRPr lang="en-US"/>
           </a:p>
         </p:txBody>
       </p:sp>
@@ -2380,8 +2380,8 @@
         </p:nvSpPr>
         <p:spPr>
           <a:xfrm>
-            <a:off x="1792288" y="459581"/>
-            <a:ext cx="5486400" cy="3086100"/>
+            <a:off x="1792288" y="612775"/>
+            <a:ext cx="5486400" cy="4114800"/>
           </a:xfrm>
         </p:spPr>
         <p:txBody>
@@ -2389,39 +2389,39 @@
           <a:lstStyle>
             <a:lvl1pPr marL="0" indent="0">
               <a:buNone/>
+              <a:defRPr sz="3200"/>
+            </a:lvl1pPr>
+            <a:lvl2pPr marL="457200" indent="0">
+              <a:buNone/>
+              <a:defRPr sz="2800"/>
+            </a:lvl2pPr>
+            <a:lvl3pPr marL="914400" indent="0">
+              <a:buNone/>
               <a:defRPr sz="2400"/>
-            </a:lvl1pPr>
-            <a:lvl2pPr marL="342900" indent="0">
-              <a:buNone/>
-              <a:defRPr sz="2100"/>
-            </a:lvl2pPr>
-            <a:lvl3pPr marL="685800" indent="0">
-              <a:buNone/>
-              <a:defRPr sz="1800"/>
             </a:lvl3pPr>
-            <a:lvl4pPr marL="1028700" indent="0">
-              <a:buNone/>
-              <a:defRPr sz="1500"/>
+            <a:lvl4pPr marL="1371600" indent="0">
+              <a:buNone/>
+              <a:defRPr sz="2000"/>
             </a:lvl4pPr>
-            <a:lvl5pPr marL="1371600" indent="0">
-              <a:buNone/>
-              <a:defRPr sz="1500"/>
+            <a:lvl5pPr marL="1828800" indent="0">
+              <a:buNone/>
+              <a:defRPr sz="2000"/>
             </a:lvl5pPr>
-            <a:lvl6pPr marL="1714500" indent="0">
-              <a:buNone/>
-              <a:defRPr sz="1500"/>
+            <a:lvl6pPr marL="2286000" indent="0">
+              <a:buNone/>
+              <a:defRPr sz="2000"/>
             </a:lvl6pPr>
-            <a:lvl7pPr marL="2057400" indent="0">
-              <a:buNone/>
-              <a:defRPr sz="1500"/>
+            <a:lvl7pPr marL="2743200" indent="0">
+              <a:buNone/>
+              <a:defRPr sz="2000"/>
             </a:lvl7pPr>
-            <a:lvl8pPr marL="2400300" indent="0">
-              <a:buNone/>
-              <a:defRPr sz="1500"/>
+            <a:lvl8pPr marL="3200400" indent="0">
+              <a:buNone/>
+              <a:defRPr sz="2000"/>
             </a:lvl8pPr>
-            <a:lvl9pPr marL="2743200" indent="0">
-              <a:buNone/>
-              <a:defRPr sz="1500"/>
+            <a:lvl9pPr marL="3657600" indent="0">
+              <a:buNone/>
+              <a:defRPr sz="2000"/>
             </a:lvl9pPr>
           </a:lstStyle>
           <a:p>
@@ -2441,8 +2441,8 @@
         </p:nvSpPr>
         <p:spPr>
           <a:xfrm>
-            <a:off x="1792288" y="4025503"/>
-            <a:ext cx="5486400" cy="603647"/>
+            <a:off x="1792288" y="5367338"/>
+            <a:ext cx="5486400" cy="804862"/>
           </a:xfrm>
         </p:spPr>
         <p:txBody>
@@ -2450,45 +2450,45 @@
           <a:lstStyle>
             <a:lvl1pPr marL="0" indent="0">
               <a:buNone/>
-              <a:defRPr sz="1050"/>
+              <a:defRPr sz="1400"/>
             </a:lvl1pPr>
-            <a:lvl2pPr marL="342900" indent="0">
+            <a:lvl2pPr marL="457200" indent="0">
+              <a:buNone/>
+              <a:defRPr sz="1200"/>
+            </a:lvl2pPr>
+            <a:lvl3pPr marL="914400" indent="0">
+              <a:buNone/>
+              <a:defRPr sz="1000"/>
+            </a:lvl3pPr>
+            <a:lvl4pPr marL="1371600" indent="0">
               <a:buNone/>
               <a:defRPr sz="900"/>
-            </a:lvl2pPr>
-            <a:lvl3pPr marL="685800" indent="0">
-              <a:buNone/>
-              <a:defRPr sz="750"/>
-            </a:lvl3pPr>
-            <a:lvl4pPr marL="1028700" indent="0">
-              <a:buNone/>
-              <a:defRPr sz="675"/>
             </a:lvl4pPr>
-            <a:lvl5pPr marL="1371600" indent="0">
-              <a:buNone/>
-              <a:defRPr sz="675"/>
+            <a:lvl5pPr marL="1828800" indent="0">
+              <a:buNone/>
+              <a:defRPr sz="900"/>
             </a:lvl5pPr>
-            <a:lvl6pPr marL="1714500" indent="0">
-              <a:buNone/>
-              <a:defRPr sz="675"/>
+            <a:lvl6pPr marL="2286000" indent="0">
+              <a:buNone/>
+              <a:defRPr sz="900"/>
             </a:lvl6pPr>
-            <a:lvl7pPr marL="2057400" indent="0">
-              <a:buNone/>
-              <a:defRPr sz="675"/>
+            <a:lvl7pPr marL="2743200" indent="0">
+              <a:buNone/>
+              <a:defRPr sz="900"/>
             </a:lvl7pPr>
-            <a:lvl8pPr marL="2400300" indent="0">
-              <a:buNone/>
-              <a:defRPr sz="675"/>
+            <a:lvl8pPr marL="3200400" indent="0">
+              <a:buNone/>
+              <a:defRPr sz="900"/>
             </a:lvl8pPr>
-            <a:lvl9pPr marL="2743200" indent="0">
-              <a:buNone/>
-              <a:defRPr sz="675"/>
+            <a:lvl9pPr marL="3657600" indent="0">
+              <a:buNone/>
+              <a:defRPr sz="900"/>
             </a:lvl9pPr>
           </a:lstStyle>
           <a:p>
             <a:pPr lvl="0"/>
             <a:r>
-              <a:rPr lang="en-US"/>
+              <a:rPr lang="en-US" smtClean="0"/>
               <a:t>Click to edit Master text styles</a:t>
             </a:r>
           </a:p>
@@ -2509,9 +2509,9 @@
           <a:bodyPr/>
           <a:lstStyle/>
           <a:p>
-            <a:fld id="{241EB5C9-1307-BA42-ABA2-0BC069CD8E7F}" type="datetimeFigureOut">
-              <a:rPr lang="en-US" smtClean="0"/>
-              <a:t>1/2/22</a:t>
+            <a:fld id="{5BCAD085-E8A6-8845-BD4E-CB4CCA059FC4}" type="datetimeFigureOut">
+              <a:rPr lang="en-US" smtClean="0"/>
+              <a:t>1/27/13</a:t>
             </a:fld>
             <a:endParaRPr lang="en-US"/>
           </a:p>
@@ -2551,7 +2551,7 @@
           <a:bodyPr/>
           <a:lstStyle/>
           <a:p>
-            <a:fld id="{C5EF2332-01BF-834F-8236-50238282D533}" type="slidenum">
+            <a:fld id="{C1FF6DA9-008F-8B48-92A6-B652298478BF}" type="slidenum">
               <a:rPr lang="en-US" smtClean="0"/>
               <a:t>‹#›</a:t>
             </a:fld>
@@ -2562,7 +2562,7 @@
     </p:spTree>
     <p:extLst>
       <p:ext uri="{BB962C8B-B14F-4D97-AF65-F5344CB8AC3E}">
-        <p14:creationId xmlns:p14="http://schemas.microsoft.com/office/powerpoint/2010/main" val="3566899855"/>
+        <p14:creationId xmlns:p14="http://schemas.microsoft.com/office/powerpoint/2010/main" val="3889236939"/>
       </p:ext>
     </p:extLst>
   </p:cSld>
@@ -2573,7 +2573,7 @@
 </file>
 
 <file path=ppt/slideMasters/slideMaster1.xml><?xml version="1.0" encoding="utf-8"?>
-<p:sldMaster xmlns:a="http://schemas.openxmlformats.org/drawingml/2006/main" xmlns:p="http://schemas.openxmlformats.org/presentationml/2006/main" xmlns:r="http://schemas.openxmlformats.org/officeDocument/2006/relationships">
+<p:sldMaster xmlns:a="http://schemas.openxmlformats.org/drawingml/2006/main" xmlns:r="http://schemas.openxmlformats.org/officeDocument/2006/relationships" xmlns:p="http://schemas.openxmlformats.org/presentationml/2006/main">
   <p:cSld>
     <p:bg>
       <p:bgRef idx="1001">
@@ -2606,23 +2606,24 @@
         </p:nvSpPr>
         <p:spPr>
           <a:xfrm>
-            <a:off x="457200" y="205979"/>
-            <a:ext cx="8229600" cy="857250"/>
+            <a:off x="457200" y="274638"/>
+            <a:ext cx="8229600" cy="1143000"/>
           </a:xfrm>
           <a:prstGeom prst="rect">
             <a:avLst/>
           </a:prstGeom>
         </p:spPr>
         <p:txBody>
-          <a:bodyPr anchor="ctr" bIns="45720" lIns="91440" rIns="91440" rtlCol="0" tIns="45720" vert="horz">
+          <a:bodyPr vert="horz" lIns="91440" tIns="45720" rIns="91440" bIns="45720" rtlCol="0" anchor="ctr">
             <a:normAutofit/>
           </a:bodyPr>
           <a:lstStyle/>
           <a:p>
             <a:r>
-              <a:rPr lang="en-US"/>
+              <a:rPr lang="en-US" smtClean="0"/>
               <a:t>Click to edit Master title style</a:t>
             </a:r>
+            <a:endParaRPr lang="en-US"/>
           </a:p>
         </p:txBody>
       </p:sp>
@@ -2633,57 +2634,58 @@
             <a:spLocks noGrp="1"/>
           </p:cNvSpPr>
           <p:nvPr>
-            <p:ph idx="1" type="body"/>
+            <p:ph type="body" idx="1"/>
           </p:nvPr>
         </p:nvSpPr>
         <p:spPr>
           <a:xfrm>
-            <a:off x="457200" y="1200151"/>
-            <a:ext cx="8229600" cy="3394472"/>
+            <a:off x="457200" y="1600200"/>
+            <a:ext cx="8229600" cy="4525963"/>
           </a:xfrm>
           <a:prstGeom prst="rect">
             <a:avLst/>
           </a:prstGeom>
         </p:spPr>
         <p:txBody>
-          <a:bodyPr bIns="45720" lIns="91440" rIns="91440" rtlCol="0" tIns="45720" vert="horz">
+          <a:bodyPr vert="horz" lIns="91440" tIns="45720" rIns="91440" bIns="45720" rtlCol="0">
             <a:normAutofit/>
           </a:bodyPr>
           <a:lstStyle/>
           <a:p>
             <a:pPr lvl="0"/>
             <a:r>
-              <a:rPr lang="en-US"/>
+              <a:rPr lang="en-US" smtClean="0"/>
               <a:t>Click to edit Master text styles</a:t>
             </a:r>
           </a:p>
           <a:p>
             <a:pPr lvl="1"/>
             <a:r>
-              <a:rPr lang="en-US"/>
+              <a:rPr lang="en-US" smtClean="0"/>
               <a:t>Second level</a:t>
             </a:r>
           </a:p>
           <a:p>
             <a:pPr lvl="2"/>
             <a:r>
-              <a:rPr lang="en-US"/>
+              <a:rPr lang="en-US" smtClean="0"/>
               <a:t>Third level</a:t>
             </a:r>
           </a:p>
           <a:p>
             <a:pPr lvl="3"/>
             <a:r>
-              <a:rPr lang="en-US"/>
+              <a:rPr lang="en-US" smtClean="0"/>
               <a:t>Fourth level</a:t>
             </a:r>
           </a:p>
           <a:p>
             <a:pPr lvl="4"/>
             <a:r>
-              <a:rPr lang="en-US"/>
+              <a:rPr lang="en-US" smtClean="0"/>
               <a:t>Fifth level</a:t>
             </a:r>
+            <a:endParaRPr lang="en-US"/>
           </a:p>
         </p:txBody>
       </p:sp>
@@ -2694,23 +2696,23 @@
             <a:spLocks noGrp="1"/>
           </p:cNvSpPr>
           <p:nvPr>
-            <p:ph idx="2" sz="half" type="dt"/>
+            <p:ph type="dt" sz="half" idx="2"/>
           </p:nvPr>
         </p:nvSpPr>
         <p:spPr>
           <a:xfrm>
-            <a:off x="457200" y="4767263"/>
-            <a:ext cx="2133600" cy="273844"/>
+            <a:off x="457200" y="6356350"/>
+            <a:ext cx="2133600" cy="365125"/>
           </a:xfrm>
           <a:prstGeom prst="rect">
             <a:avLst/>
           </a:prstGeom>
         </p:spPr>
         <p:txBody>
-          <a:bodyPr anchor="ctr" bIns="45720" lIns="91440" rIns="91440" rtlCol="0" tIns="45720" vert="horz"/>
+          <a:bodyPr vert="horz" lIns="91440" tIns="45720" rIns="91440" bIns="45720" rtlCol="0" anchor="ctr"/>
           <a:lstStyle>
             <a:lvl1pPr algn="l">
-              <a:defRPr sz="900">
+              <a:defRPr sz="1200">
                 <a:solidFill>
                   <a:schemeClr val="tx1">
                     <a:tint val="75000"/>
@@ -2720,9 +2722,9 @@
             </a:lvl1pPr>
           </a:lstStyle>
           <a:p>
-            <a:fld id="{241EB5C9-1307-BA42-ABA2-0BC069CD8E7F}" type="datetimeFigureOut">
-              <a:rPr lang="en-US" smtClean="0"/>
-              <a:t>1/2/22</a:t>
+            <a:fld id="{5BCAD085-E8A6-8845-BD4E-CB4CCA059FC4}" type="datetimeFigureOut">
+              <a:rPr lang="en-US" smtClean="0"/>
+              <a:t>1/27/13</a:t>
             </a:fld>
             <a:endParaRPr lang="en-US"/>
           </a:p>
@@ -2735,23 +2737,23 @@
             <a:spLocks noGrp="1"/>
           </p:cNvSpPr>
           <p:nvPr>
-            <p:ph idx="3" sz="quarter" type="ftr"/>
+            <p:ph type="ftr" sz="quarter" idx="3"/>
           </p:nvPr>
         </p:nvSpPr>
         <p:spPr>
           <a:xfrm>
-            <a:off x="3124200" y="4767263"/>
-            <a:ext cx="2895600" cy="273844"/>
+            <a:off x="3124200" y="6356350"/>
+            <a:ext cx="2895600" cy="365125"/>
           </a:xfrm>
           <a:prstGeom prst="rect">
             <a:avLst/>
           </a:prstGeom>
         </p:spPr>
         <p:txBody>
-          <a:bodyPr anchor="ctr" bIns="45720" lIns="91440" rIns="91440" rtlCol="0" tIns="45720" vert="horz"/>
+          <a:bodyPr vert="horz" lIns="91440" tIns="45720" rIns="91440" bIns="45720" rtlCol="0" anchor="ctr"/>
           <a:lstStyle>
             <a:lvl1pPr algn="ctr">
-              <a:defRPr sz="900">
+              <a:defRPr sz="1200">
                 <a:solidFill>
                   <a:schemeClr val="tx1">
                     <a:tint val="75000"/>
@@ -2772,23 +2774,23 @@
             <a:spLocks noGrp="1"/>
           </p:cNvSpPr>
           <p:nvPr>
-            <p:ph idx="4" sz="quarter" type="sldNum"/>
+            <p:ph type="sldNum" sz="quarter" idx="4"/>
           </p:nvPr>
         </p:nvSpPr>
         <p:spPr>
           <a:xfrm>
-            <a:off x="6553200" y="4767263"/>
-            <a:ext cx="2133600" cy="273844"/>
+            <a:off x="6553200" y="6356350"/>
+            <a:ext cx="2133600" cy="365125"/>
           </a:xfrm>
           <a:prstGeom prst="rect">
             <a:avLst/>
           </a:prstGeom>
         </p:spPr>
         <p:txBody>
-          <a:bodyPr anchor="ctr" bIns="45720" lIns="91440" rIns="91440" rtlCol="0" tIns="45720" vert="horz"/>
+          <a:bodyPr vert="horz" lIns="91440" tIns="45720" rIns="91440" bIns="45720" rtlCol="0" anchor="ctr"/>
           <a:lstStyle>
             <a:lvl1pPr algn="r">
-              <a:defRPr sz="900">
+              <a:defRPr sz="1200">
                 <a:solidFill>
                   <a:schemeClr val="tx1">
                     <a:tint val="75000"/>
@@ -2798,7 +2800,7 @@
             </a:lvl1pPr>
           </a:lstStyle>
           <a:p>
-            <a:fld id="{C5EF2332-01BF-834F-8236-50238282D533}" type="slidenum">
+            <a:fld id="{C1FF6DA9-008F-8B48-92A6-B652298478BF}" type="slidenum">
               <a:rPr lang="en-US" smtClean="0"/>
               <a:t>‹#›</a:t>
             </a:fld>
@@ -2809,11 +2811,11 @@
     </p:spTree>
     <p:extLst>
       <p:ext uri="{BB962C8B-B14F-4D97-AF65-F5344CB8AC3E}">
-        <p14:creationId xmlns:p14="http://schemas.microsoft.com/office/powerpoint/2010/main" val="3676200875"/>
+        <p14:creationId xmlns:p14="http://schemas.microsoft.com/office/powerpoint/2010/main" val="2209977519"/>
       </p:ext>
     </p:extLst>
   </p:cSld>
-  <p:clrMap accent1="accent1" accent2="accent2" accent3="accent3" accent4="accent4" accent5="accent5" accent6="accent6" bg1="lt1" bg2="lt2" folHlink="folHlink" hlink="hlink" tx1="dk1" tx2="dk2"/>
+  <p:clrMap bg1="lt1" tx1="dk1" bg2="lt2" tx2="dk2" accent1="accent1" accent2="accent2" accent3="accent3" accent4="accent4" accent5="accent5" accent6="accent6" hlink="hlink" folHlink="folHlink"/>
   <p:sldLayoutIdLst>
     <p:sldLayoutId id="2147483649" r:id="rId1"/>
     <p:sldLayoutId id="2147483650" r:id="rId2"/>
@@ -2829,12 +2831,12 @@
   </p:sldLayoutIdLst>
   <p:txStyles>
     <p:titleStyle>
-      <a:lvl1pPr algn="ctr" defTabSz="342900" eaLnBrk="1" hangingPunct="1" latinLnBrk="0" rtl="0">
+      <a:lvl1pPr algn="ctr" defTabSz="457200" rtl="0" eaLnBrk="1" latinLnBrk="0" hangingPunct="1">
         <a:spcBef>
           <a:spcPct val="0"/>
         </a:spcBef>
         <a:buNone/>
-        <a:defRPr kern="1200" sz="3300">
+        <a:defRPr sz="4400" kern="1200">
           <a:solidFill>
             <a:schemeClr val="tx1"/>
           </a:solidFill>
@@ -2845,13 +2847,13 @@
       </a:lvl1pPr>
     </p:titleStyle>
     <p:bodyStyle>
-      <a:lvl1pPr algn="l" defTabSz="342900" eaLnBrk="1" hangingPunct="1" indent="-342900" latinLnBrk="0" marL="342900" rtl="0">
+      <a:lvl1pPr marL="342900" indent="-342900" algn="l" defTabSz="457200" rtl="0" eaLnBrk="1" latinLnBrk="0" hangingPunct="1">
         <a:spcBef>
           <a:spcPct val="20000"/>
         </a:spcBef>
         <a:buFont typeface="Arial"/>
         <a:buChar char="•"/>
-        <a:defRPr kern="1200" sz="2400">
+        <a:defRPr sz="3200" kern="1200">
           <a:solidFill>
             <a:schemeClr val="tx1"/>
           </a:solidFill>
@@ -2860,13 +2862,13 @@
           <a:cs typeface="+mn-cs"/>
         </a:defRPr>
       </a:lvl1pPr>
-      <a:lvl2pPr algn="l" defTabSz="342900" eaLnBrk="1" hangingPunct="1" indent="-342900" latinLnBrk="0" marL="685800" rtl="0">
+      <a:lvl2pPr marL="742950" indent="-285750" algn="l" defTabSz="457200" rtl="0" eaLnBrk="1" latinLnBrk="0" hangingPunct="1">
         <a:spcBef>
           <a:spcPct val="20000"/>
         </a:spcBef>
         <a:buFont typeface="Arial"/>
         <a:buChar char="–"/>
-        <a:defRPr kern="1200" sz="2100">
+        <a:defRPr sz="2800" kern="1200">
           <a:solidFill>
             <a:schemeClr val="tx1"/>
           </a:solidFill>
@@ -2875,13 +2877,13 @@
           <a:cs typeface="+mn-cs"/>
         </a:defRPr>
       </a:lvl2pPr>
-      <a:lvl3pPr algn="l" defTabSz="342900" eaLnBrk="1" hangingPunct="1" indent="-342900" latinLnBrk="0" marL="1028700" rtl="0">
+      <a:lvl3pPr marL="1143000" indent="-228600" algn="l" defTabSz="457200" rtl="0" eaLnBrk="1" latinLnBrk="0" hangingPunct="1">
         <a:spcBef>
           <a:spcPct val="20000"/>
         </a:spcBef>
         <a:buFont typeface="Arial"/>
         <a:buChar char="•"/>
-        <a:defRPr kern="1200" sz="1800">
+        <a:defRPr sz="2400" kern="1200">
           <a:solidFill>
             <a:schemeClr val="tx1"/>
           </a:solidFill>
@@ -2890,13 +2892,13 @@
           <a:cs typeface="+mn-cs"/>
         </a:defRPr>
       </a:lvl3pPr>
-      <a:lvl4pPr algn="l" defTabSz="342900" eaLnBrk="1" hangingPunct="1" indent="-342900" latinLnBrk="0" marL="1371600" rtl="0">
+      <a:lvl4pPr marL="1600200" indent="-228600" algn="l" defTabSz="457200" rtl="0" eaLnBrk="1" latinLnBrk="0" hangingPunct="1">
         <a:spcBef>
           <a:spcPct val="20000"/>
         </a:spcBef>
         <a:buFont typeface="Arial"/>
         <a:buChar char="–"/>
-        <a:defRPr kern="1200" sz="1500">
+        <a:defRPr sz="2000" kern="1200">
           <a:solidFill>
             <a:schemeClr val="tx1"/>
           </a:solidFill>
@@ -2905,13 +2907,13 @@
           <a:cs typeface="+mn-cs"/>
         </a:defRPr>
       </a:lvl4pPr>
-      <a:lvl5pPr algn="l" defTabSz="342900" eaLnBrk="1" hangingPunct="1" indent="-342900" latinLnBrk="0" marL="1714500" rtl="0">
+      <a:lvl5pPr marL="2057400" indent="-228600" algn="l" defTabSz="457200" rtl="0" eaLnBrk="1" latinLnBrk="0" hangingPunct="1">
         <a:spcBef>
           <a:spcPct val="20000"/>
         </a:spcBef>
         <a:buFont typeface="Arial"/>
         <a:buChar char="»"/>
-        <a:defRPr kern="1200" sz="1500">
+        <a:defRPr sz="2000" kern="1200">
           <a:solidFill>
             <a:schemeClr val="tx1"/>
           </a:solidFill>
@@ -2920,13 +2922,13 @@
           <a:cs typeface="+mn-cs"/>
         </a:defRPr>
       </a:lvl5pPr>
-      <a:lvl6pPr algn="l" defTabSz="342900" eaLnBrk="1" hangingPunct="1" indent="-342900" latinLnBrk="0" marL="2057400" rtl="0">
+      <a:lvl6pPr marL="2514600" indent="-228600" algn="l" defTabSz="457200" rtl="0" eaLnBrk="1" latinLnBrk="0" hangingPunct="1">
         <a:spcBef>
           <a:spcPct val="20000"/>
         </a:spcBef>
         <a:buFont typeface="Arial"/>
         <a:buChar char="•"/>
-        <a:defRPr kern="1200" sz="1500">
+        <a:defRPr sz="2000" kern="1200">
           <a:solidFill>
             <a:schemeClr val="tx1"/>
           </a:solidFill>
@@ -2935,13 +2937,13 @@
           <a:cs typeface="+mn-cs"/>
         </a:defRPr>
       </a:lvl6pPr>
-      <a:lvl7pPr algn="l" defTabSz="342900" eaLnBrk="1" hangingPunct="1" indent="-342900" latinLnBrk="0" marL="2400300" rtl="0">
+      <a:lvl7pPr marL="2971800" indent="-228600" algn="l" defTabSz="457200" rtl="0" eaLnBrk="1" latinLnBrk="0" hangingPunct="1">
         <a:spcBef>
           <a:spcPct val="20000"/>
         </a:spcBef>
         <a:buFont typeface="Arial"/>
         <a:buChar char="•"/>
-        <a:defRPr kern="1200" sz="1500">
+        <a:defRPr sz="2000" kern="1200">
           <a:solidFill>
             <a:schemeClr val="tx1"/>
           </a:solidFill>
@@ -2950,13 +2952,13 @@
           <a:cs typeface="+mn-cs"/>
         </a:defRPr>
       </a:lvl7pPr>
-      <a:lvl8pPr algn="l" defTabSz="342900" eaLnBrk="1" hangingPunct="1" indent="-342900" latinLnBrk="0" marL="2743200" rtl="0">
+      <a:lvl8pPr marL="3429000" indent="-228600" algn="l" defTabSz="457200" rtl="0" eaLnBrk="1" latinLnBrk="0" hangingPunct="1">
         <a:spcBef>
           <a:spcPct val="20000"/>
         </a:spcBef>
         <a:buFont typeface="Arial"/>
         <a:buChar char="•"/>
-        <a:defRPr kern="1200" sz="1500">
+        <a:defRPr sz="2000" kern="1200">
           <a:solidFill>
             <a:schemeClr val="tx1"/>
           </a:solidFill>
@@ -2965,13 +2967,13 @@
           <a:cs typeface="+mn-cs"/>
         </a:defRPr>
       </a:lvl8pPr>
-      <a:lvl9pPr algn="l" defTabSz="342900" eaLnBrk="1" hangingPunct="1" indent="-342900" latinLnBrk="0" marL="3086100" rtl="0">
+      <a:lvl9pPr marL="3886200" indent="-228600" algn="l" defTabSz="457200" rtl="0" eaLnBrk="1" latinLnBrk="0" hangingPunct="1">
         <a:spcBef>
           <a:spcPct val="20000"/>
         </a:spcBef>
         <a:buFont typeface="Arial"/>
         <a:buChar char="•"/>
-        <a:defRPr kern="1200" sz="1500">
+        <a:defRPr sz="2000" kern="1200">
           <a:solidFill>
             <a:schemeClr val="tx1"/>
           </a:solidFill>
@@ -2985,8 +2987,8 @@
       <a:defPPr>
         <a:defRPr lang="en-US"/>
       </a:defPPr>
-      <a:lvl1pPr algn="l" defTabSz="342900" eaLnBrk="1" hangingPunct="1" latinLnBrk="0" marL="0" rtl="0">
-        <a:defRPr kern="1200" sz="1350">
+      <a:lvl1pPr marL="0" algn="l" defTabSz="457200" rtl="0" eaLnBrk="1" latinLnBrk="0" hangingPunct="1">
+        <a:defRPr sz="1800" kern="1200">
           <a:solidFill>
             <a:schemeClr val="tx1"/>
           </a:solidFill>
@@ -2995,8 +2997,8 @@
           <a:cs typeface="+mn-cs"/>
         </a:defRPr>
       </a:lvl1pPr>
-      <a:lvl2pPr algn="l" defTabSz="342900" eaLnBrk="1" hangingPunct="1" latinLnBrk="0" marL="342900" rtl="0">
-        <a:defRPr kern="1200" sz="1350">
+      <a:lvl2pPr marL="457200" algn="l" defTabSz="457200" rtl="0" eaLnBrk="1" latinLnBrk="0" hangingPunct="1">
+        <a:defRPr sz="1800" kern="1200">
           <a:solidFill>
             <a:schemeClr val="tx1"/>
           </a:solidFill>
@@ -3005,8 +3007,8 @@
           <a:cs typeface="+mn-cs"/>
         </a:defRPr>
       </a:lvl2pPr>
-      <a:lvl3pPr algn="l" defTabSz="342900" eaLnBrk="1" hangingPunct="1" latinLnBrk="0" marL="685800" rtl="0">
-        <a:defRPr kern="1200" sz="1350">
+      <a:lvl3pPr marL="914400" algn="l" defTabSz="457200" rtl="0" eaLnBrk="1" latinLnBrk="0" hangingPunct="1">
+        <a:defRPr sz="1800" kern="1200">
           <a:solidFill>
             <a:schemeClr val="tx1"/>
           </a:solidFill>
@@ -3015,8 +3017,8 @@
           <a:cs typeface="+mn-cs"/>
         </a:defRPr>
       </a:lvl3pPr>
-      <a:lvl4pPr algn="l" defTabSz="342900" eaLnBrk="1" hangingPunct="1" latinLnBrk="0" marL="1028700" rtl="0">
-        <a:defRPr kern="1200" sz="1350">
+      <a:lvl4pPr marL="1371600" algn="l" defTabSz="457200" rtl="0" eaLnBrk="1" latinLnBrk="0" hangingPunct="1">
+        <a:defRPr sz="1800" kern="1200">
           <a:solidFill>
             <a:schemeClr val="tx1"/>
           </a:solidFill>
@@ -3025,8 +3027,8 @@
           <a:cs typeface="+mn-cs"/>
         </a:defRPr>
       </a:lvl4pPr>
-      <a:lvl5pPr algn="l" defTabSz="342900" eaLnBrk="1" hangingPunct="1" latinLnBrk="0" marL="1371600" rtl="0">
-        <a:defRPr kern="1200" sz="1350">
+      <a:lvl5pPr marL="1828800" algn="l" defTabSz="457200" rtl="0" eaLnBrk="1" latinLnBrk="0" hangingPunct="1">
+        <a:defRPr sz="1800" kern="1200">
           <a:solidFill>
             <a:schemeClr val="tx1"/>
           </a:solidFill>
@@ -3035,8 +3037,8 @@
           <a:cs typeface="+mn-cs"/>
         </a:defRPr>
       </a:lvl5pPr>
-      <a:lvl6pPr algn="l" defTabSz="342900" eaLnBrk="1" hangingPunct="1" latinLnBrk="0" marL="1714500" rtl="0">
-        <a:defRPr kern="1200" sz="1350">
+      <a:lvl6pPr marL="2286000" algn="l" defTabSz="457200" rtl="0" eaLnBrk="1" latinLnBrk="0" hangingPunct="1">
+        <a:defRPr sz="1800" kern="1200">
           <a:solidFill>
             <a:schemeClr val="tx1"/>
           </a:solidFill>
@@ -3045,8 +3047,8 @@
           <a:cs typeface="+mn-cs"/>
         </a:defRPr>
       </a:lvl6pPr>
-      <a:lvl7pPr algn="l" defTabSz="342900" eaLnBrk="1" hangingPunct="1" latinLnBrk="0" marL="2057400" rtl="0">
-        <a:defRPr kern="1200" sz="1350">
+      <a:lvl7pPr marL="2743200" algn="l" defTabSz="457200" rtl="0" eaLnBrk="1" latinLnBrk="0" hangingPunct="1">
+        <a:defRPr sz="1800" kern="1200">
           <a:solidFill>
             <a:schemeClr val="tx1"/>
           </a:solidFill>
@@ -3055,8 +3057,8 @@
           <a:cs typeface="+mn-cs"/>
         </a:defRPr>
       </a:lvl7pPr>
-      <a:lvl8pPr algn="l" defTabSz="342900" eaLnBrk="1" hangingPunct="1" latinLnBrk="0" marL="2400300" rtl="0">
-        <a:defRPr kern="1200" sz="1350">
+      <a:lvl8pPr marL="3200400" algn="l" defTabSz="457200" rtl="0" eaLnBrk="1" latinLnBrk="0" hangingPunct="1">
+        <a:defRPr sz="1800" kern="1200">
           <a:solidFill>
             <a:schemeClr val="tx1"/>
           </a:solidFill>
@@ -3065,8 +3067,8 @@
           <a:cs typeface="+mn-cs"/>
         </a:defRPr>
       </a:lvl8pPr>
-      <a:lvl9pPr algn="l" defTabSz="342900" eaLnBrk="1" hangingPunct="1" latinLnBrk="0" marL="2743200" rtl="0">
-        <a:defRPr kern="1200" sz="1350">
+      <a:lvl9pPr marL="3657600" algn="l" defTabSz="457200" rtl="0" eaLnBrk="1" latinLnBrk="0" hangingPunct="1">
+        <a:defRPr sz="1800" kern="1200">
           <a:solidFill>
             <a:schemeClr val="tx1"/>
           </a:solidFill>
@@ -3081,7 +3083,7 @@
 </file>
 
 <file path=ppt/slides/slide1.xml><?xml version="1.0" encoding="utf-8"?>
-<p:sld xmlns:a="http://schemas.openxmlformats.org/drawingml/2006/main" xmlns:r="http://schemas.openxmlformats.org/officeDocument/2006/relationships" xmlns:p="http://schemas.openxmlformats.org/presentationml/2006/main">
+<p:sld xmlns:a="http://schemas.openxmlformats.org/drawingml/2006/main" xmlns:p="http://schemas.openxmlformats.org/presentationml/2006/main" xmlns:r="http://schemas.openxmlformats.org/officeDocument/2006/relationships">
   <p:cSld>
     <p:spTree>
       <p:nvGrpSpPr>
@@ -3089,14 +3091,7 @@
         <p:cNvGrpSpPr/>
         <p:nvPr/>
       </p:nvGrpSpPr>
-      <p:grpSpPr>
-        <a:xfrm>
-          <a:off x="0" y="0"/>
-          <a:ext cx="0" cy="0"/>
-          <a:chOff x="0" y="0"/>
-          <a:chExt cx="0" cy="0"/>
-        </a:xfrm>
-      </p:grpSpPr>
+      <p:grpSpPr/>
       <p:sp>
         <p:nvSpPr>
           <p:cNvPr id="2" name="Title 1"/>
@@ -3104,36 +3099,61 @@
             <a:spLocks noGrp="1"/>
           </p:cNvSpPr>
           <p:nvPr>
-            <p:ph type="title"/>
-          </p:nvPr>
-        </p:nvSpPr>
-        <p:spPr>
-          <a:xfrm>
-            <a:off x="722313" y="3305176"/>
-            <a:ext cx="7772400" cy="1021556"/>
-          </a:xfrm>
-        </p:spPr>
-        <p:txBody>
-          <a:bodyPr/>
-          <a:lstStyle/>
-          <a:p>
-            <a:pPr lvl="0" indent="0" marL="0">
-              <a:buNone/>
-            </a:pPr>
-            <a:r>
-              <a:rPr/>
-              <a:t>PPT Structure: AI-Powered Fake News Detection</a:t>
+            <p:ph type="ctrTitle"/>
+          </p:nvPr>
+        </p:nvSpPr>
+        <p:spPr/>
+        <p:txBody>
+          <a:bodyPr/>
+          <a:lstStyle/>
+          <a:p>
+            <a:r>
+              <a:t>AI-Powered Fake News Detection Using Text Classification</a:t>
+            </a:r>
+          </a:p>
+        </p:txBody>
+      </p:sp>
+      <p:sp>
+        <p:nvSpPr>
+          <p:cNvPr id="3" name="Subtitle 2"/>
+          <p:cNvSpPr>
+            <a:spLocks noGrp="1"/>
+          </p:cNvSpPr>
+          <p:nvPr>
+            <p:ph type="subTitle" idx="1"/>
+          </p:nvPr>
+        </p:nvSpPr>
+        <p:spPr/>
+        <p:txBody>
+          <a:bodyPr/>
+          <a:lstStyle/>
+          <a:p>
+            <a:r>
+              <a:t>Presented by: K Venkatesh Hebbar</a:t>
+            </a:r>
+          </a:p>
+          <a:p>
+            <a:r>
+              <a:t>Roll No: 595766</a:t>
+            </a:r>
+          </a:p>
+          <a:p>
+            <a:r>
+              <a:t>NMAM Institute of Technology</a:t>
             </a:r>
           </a:p>
         </p:txBody>
       </p:sp>
     </p:spTree>
   </p:cSld>
+  <p:clrMapOvr>
+    <a:masterClrMapping/>
+  </p:clrMapOvr>
 </p:sld>
 </file>
 
 <file path=ppt/slides/slide2.xml><?xml version="1.0" encoding="utf-8"?>
-<p:sld xmlns:a="http://schemas.openxmlformats.org/drawingml/2006/main" xmlns:r="http://schemas.openxmlformats.org/officeDocument/2006/relationships" xmlns:p="http://schemas.openxmlformats.org/presentationml/2006/main">
+<p:sld xmlns:a="http://schemas.openxmlformats.org/drawingml/2006/main" xmlns:p="http://schemas.openxmlformats.org/presentationml/2006/main" xmlns:r="http://schemas.openxmlformats.org/officeDocument/2006/relationships">
   <p:cSld>
     <p:spTree>
       <p:nvGrpSpPr>
@@ -3141,14 +3161,7 @@
         <p:cNvGrpSpPr/>
         <p:nvPr/>
       </p:nvGrpSpPr>
-      <p:grpSpPr>
-        <a:xfrm>
-          <a:off x="0" y="0"/>
-          <a:ext cx="0" cy="0"/>
-          <a:chOff x="0" y="0"/>
-          <a:chExt cx="0" cy="0"/>
-        </a:xfrm>
-      </p:grpSpPr>
+      <p:grpSpPr/>
       <p:sp>
         <p:nvSpPr>
           <p:cNvPr id="2" name="Title 1"/>
@@ -3164,12 +3177,8 @@
           <a:bodyPr/>
           <a:lstStyle/>
           <a:p>
-            <a:pPr lvl="0" indent="0" marL="0">
-              <a:buNone/>
-            </a:pPr>
-            <a:r>
-              <a:rPr/>
-              <a:t>Slide 1: Title</a:t>
+            <a:r>
+              <a:t>Introduction</a:t>
             </a:r>
           </a:p>
         </p:txBody>
@@ -3189,59 +3198,32 @@
           <a:bodyPr/>
           <a:lstStyle/>
           <a:p>
-            <a:pPr lvl="0" indent="0" marL="0">
-              <a:buNone/>
-            </a:pPr>
-            <a:r>
-              <a:rPr b="1"/>
-              <a:t>Title:</a:t>
-            </a:r>
-            <a:r>
-              <a:rPr/>
-              <a:t> AI-Powered Fake News Detection Using Text Classification </a:t>
-            </a:r>
-            <a:r>
-              <a:rPr b="1"/>
-              <a:t>Subtitle:</a:t>
-            </a:r>
-            <a:r>
-              <a:rPr/>
-              <a:t> A Machine Learning Approach to Combating Misinformation </a:t>
-            </a:r>
-            <a:r>
-              <a:rPr b="1"/>
-              <a:t>Presenter:</a:t>
-            </a:r>
-            <a:r>
-              <a:rPr/>
-              <a:t> Venkatesh Hebbar </a:t>
-            </a:r>
-            <a:r>
-              <a:rPr b="1"/>
-              <a:t>Roll No:</a:t>
-            </a:r>
-            <a:r>
-              <a:rPr/>
-              <a:t> 595766 </a:t>
-            </a:r>
-            <a:r>
-              <a:rPr b="1"/>
-              <a:t>College:</a:t>
-            </a:r>
-            <a:r>
-              <a:rPr/>
-              <a:t> NMAM Institute of Technology</a:t>
+            <a:r>
+              <a:t>• Objective: Build an AI to detect Fake News.</a:t>
+            </a:r>
+          </a:p>
+          <a:p>
+            <a:r>
+              <a:t>• Approach: NLP with TF-IDF Vectorization.</a:t>
+            </a:r>
+          </a:p>
+          <a:p>
+            <a:r>
+              <a:t>• Algorithms: Logistic Regression, Random Forest, Naive Bayes, MLP.</a:t>
             </a:r>
           </a:p>
         </p:txBody>
       </p:sp>
     </p:spTree>
   </p:cSld>
+  <p:clrMapOvr>
+    <a:masterClrMapping/>
+  </p:clrMapOvr>
 </p:sld>
 </file>
 
 <file path=ppt/slides/slide3.xml><?xml version="1.0" encoding="utf-8"?>
-<p:sld xmlns:a="http://schemas.openxmlformats.org/drawingml/2006/main" xmlns:r="http://schemas.openxmlformats.org/officeDocument/2006/relationships" xmlns:p="http://schemas.openxmlformats.org/presentationml/2006/main">
+<p:sld xmlns:a="http://schemas.openxmlformats.org/drawingml/2006/main" xmlns:p="http://schemas.openxmlformats.org/presentationml/2006/main" xmlns:r="http://schemas.openxmlformats.org/officeDocument/2006/relationships">
   <p:cSld>
     <p:spTree>
       <p:nvGrpSpPr>
@@ -3249,14 +3231,7 @@
         <p:cNvGrpSpPr/>
         <p:nvPr/>
       </p:nvGrpSpPr>
-      <p:grpSpPr>
-        <a:xfrm>
-          <a:off x="0" y="0"/>
-          <a:ext cx="0" cy="0"/>
-          <a:chOff x="0" y="0"/>
-          <a:chExt cx="0" cy="0"/>
-        </a:xfrm>
-      </p:grpSpPr>
+      <p:grpSpPr/>
       <p:sp>
         <p:nvSpPr>
           <p:cNvPr id="2" name="Title 1"/>
@@ -3272,192 +3247,17 @@
           <a:bodyPr/>
           <a:lstStyle/>
           <a:p>
-            <a:pPr lvl="0" indent="0" marL="0">
-              <a:buNone/>
-            </a:pPr>
-            <a:r>
-              <a:rPr/>
-              <a:t>Slide 2: Introduction &amp; Problem Statement</a:t>
-            </a:r>
-          </a:p>
-        </p:txBody>
-      </p:sp>
-      <p:sp>
-        <p:nvSpPr>
-          <p:cNvPr id="3" name="Content Placeholder 2"/>
-          <p:cNvSpPr>
-            <a:spLocks noGrp="1"/>
-          </p:cNvSpPr>
-          <p:nvPr>
-            <p:ph idx="1"/>
-          </p:nvPr>
-        </p:nvSpPr>
-        <p:spPr/>
-        <p:txBody>
-          <a:bodyPr/>
-          <a:lstStyle/>
-          <a:p>
-            <a:pPr lvl="0" indent="0" marL="0">
-              <a:buNone/>
-            </a:pPr>
-            <a:r>
-              <a:rPr b="1"/>
-              <a:t>Introduction:</a:t>
-            </a:r>
-            <a:r>
-              <a:rPr/>
-              <a:t> - Fake news spreads rapidly on social media, eroding public trust and causing societal harm. - Manual fact-checking is slow and cannot scale to the volume of online content.</a:t>
-            </a:r>
-          </a:p>
-          <a:p>
-            <a:pPr lvl="0" indent="0" marL="0">
-              <a:buNone/>
-            </a:pPr>
-            <a:r>
-              <a:rPr b="1"/>
-              <a:t>Problem Statement:</a:t>
-            </a:r>
-            <a:r>
-              <a:rPr/>
-              <a:t> - To design an automated, AI-driven system capable of classifying news articles as “Fake” or “Real” based solely on their textual content. - Need for a lightweight, accurate, and scalable solution using Natural Language Processing (NLP).</a:t>
-            </a:r>
-          </a:p>
-        </p:txBody>
-      </p:sp>
-    </p:spTree>
-  </p:cSld>
-</p:sld>
-</file>
-
-<file path=ppt/slides/slide4.xml><?xml version="1.0" encoding="utf-8"?>
-<p:sld xmlns:a="http://schemas.openxmlformats.org/drawingml/2006/main" xmlns:r="http://schemas.openxmlformats.org/officeDocument/2006/relationships" xmlns:p="http://schemas.openxmlformats.org/presentationml/2006/main">
-  <p:cSld>
-    <p:spTree>
-      <p:nvGrpSpPr>
-        <p:cNvPr id="1" name=""/>
-        <p:cNvGrpSpPr/>
-        <p:nvPr/>
-      </p:nvGrpSpPr>
-      <p:grpSpPr>
-        <a:xfrm>
-          <a:off x="0" y="0"/>
-          <a:ext cx="0" cy="0"/>
-          <a:chOff x="0" y="0"/>
-          <a:chExt cx="0" cy="0"/>
-        </a:xfrm>
-      </p:grpSpPr>
-      <p:sp>
-        <p:nvSpPr>
-          <p:cNvPr id="2" name="Title 1"/>
-          <p:cNvSpPr>
-            <a:spLocks noGrp="1"/>
-          </p:cNvSpPr>
-          <p:nvPr>
-            <p:ph type="title"/>
-          </p:nvPr>
-        </p:nvSpPr>
-        <p:spPr>
-          <a:xfrm>
-            <a:off x="457201" y="204787"/>
-            <a:ext cx="3008313" cy="871538"/>
-          </a:xfrm>
-        </p:spPr>
-        <p:txBody>
-          <a:bodyPr/>
-          <a:lstStyle/>
-          <a:p>
-            <a:pPr lvl="0" indent="0" marL="0">
-              <a:buNone/>
-            </a:pPr>
-            <a:r>
-              <a:rPr/>
-              <a:t>Slide 3: Methodology</a:t>
-            </a:r>
-          </a:p>
-        </p:txBody>
-      </p:sp>
-      <p:sp>
-        <p:nvSpPr>
-          <p:cNvPr id="4" name="Text Placeholder 3"/>
-          <p:cNvSpPr>
-            <a:spLocks noGrp="1"/>
-          </p:cNvSpPr>
-          <p:nvPr>
-            <p:ph idx="2" sz="half" type="body"/>
-          </p:nvPr>
-        </p:nvSpPr>
-        <p:spPr/>
-        <p:txBody>
-          <a:bodyPr/>
-          <a:lstStyle/>
-          <a:p>
-            <a:pPr lvl="0" indent="0" marL="0">
-              <a:buNone/>
-            </a:pPr>
-            <a:r>
-              <a:rPr b="1"/>
-              <a:t>System Workflow:</a:t>
-            </a:r>
-            <a:r>
-              <a:rPr/>
-              <a:t> 1. </a:t>
-            </a:r>
-            <a:r>
-              <a:rPr b="1"/>
-              <a:t>Dataset Collection:</a:t>
-            </a:r>
-            <a:r>
-              <a:rPr/>
-              <a:t> Curated dataset of 1,000 balanced Fake and Real news records. 2. </a:t>
-            </a:r>
-            <a:r>
-              <a:rPr b="1"/>
-              <a:t>Data Preprocessing:</a:t>
-            </a:r>
-            <a:r>
-              <a:rPr/>
-              <a:t> Lowercasing, removing HTML, punctuation, URLs, emojis, and stopwords. 3. </a:t>
-            </a:r>
-            <a:r>
-              <a:rPr b="1"/>
-              <a:t>Feature Extraction:</a:t>
-            </a:r>
-            <a:r>
-              <a:rPr/>
-              <a:t> TF-IDF Vectorization combined with Character N-Grams (3-5 chars) to handle out-of-vocabulary words. 4. </a:t>
-            </a:r>
-            <a:r>
-              <a:rPr b="1"/>
-              <a:t>Train/Test Split:</a:t>
-            </a:r>
-            <a:r>
-              <a:rPr/>
-              <a:t> 80% Training Data, 20% Testing Data. 5. </a:t>
-            </a:r>
-            <a:r>
-              <a:rPr b="1"/>
-              <a:t>Model Training:</a:t>
-            </a:r>
-            <a:r>
-              <a:rPr/>
-              <a:t> Fitting classifiers to the feature vectors. 6. </a:t>
-            </a:r>
-            <a:r>
-              <a:rPr b="1"/>
-              <a:t>Prediction:</a:t>
-            </a:r>
-            <a:r>
-              <a:rPr/>
-              <a:t> Deploying the best model in an interactive web interface.</a:t>
+            <a:r>
+              <a:t>System Architecture &amp; Workflow</a:t>
             </a:r>
           </a:p>
         </p:txBody>
       </p:sp>
       <p:pic>
         <p:nvPicPr>
-          <p:cNvPr descr="../workflow_diagram.png" id="0" name="Picture 1"/>
+          <p:cNvPr id="3" name="Picture 2" descr="workflow_diagram.png"/>
           <p:cNvPicPr>
-            <a:picLocks noGrp="1" noChangeAspect="1"/>
+            <a:picLocks noChangeAspect="1"/>
           </p:cNvPicPr>
           <p:nvPr/>
         </p:nvPicPr>
@@ -3467,29 +3267,26 @@
             <a:fillRect/>
           </a:stretch>
         </p:blipFill>
-        <p:spPr bwMode="auto">
+        <p:spPr>
           <a:xfrm>
-            <a:off x="3568700" y="863600"/>
-            <a:ext cx="5105400" cy="3060700"/>
+            <a:off x="914400" y="1828800"/>
+            <a:ext cx="7315200" cy="4389120"/>
           </a:xfrm>
           <a:prstGeom prst="rect">
             <a:avLst/>
           </a:prstGeom>
-          <a:noFill/>
-          <a:ln w="9525">
-            <a:noFill/>
-            <a:headEnd/>
-            <a:tailEnd/>
-          </a:ln>
         </p:spPr>
       </p:pic>
     </p:spTree>
   </p:cSld>
+  <p:clrMapOvr>
+    <a:masterClrMapping/>
+  </p:clrMapOvr>
 </p:sld>
 </file>
 
-<file path=ppt/slides/slide5.xml><?xml version="1.0" encoding="utf-8"?>
-<p:sld xmlns:a="http://schemas.openxmlformats.org/drawingml/2006/main" xmlns:r="http://schemas.openxmlformats.org/officeDocument/2006/relationships" xmlns:p="http://schemas.openxmlformats.org/presentationml/2006/main">
+<file path=ppt/slides/slide4.xml><?xml version="1.0" encoding="utf-8"?>
+<p:sld xmlns:a="http://schemas.openxmlformats.org/drawingml/2006/main" xmlns:p="http://schemas.openxmlformats.org/presentationml/2006/main" xmlns:r="http://schemas.openxmlformats.org/officeDocument/2006/relationships">
   <p:cSld>
     <p:spTree>
       <p:nvGrpSpPr>
@@ -3497,14 +3294,7 @@
         <p:cNvGrpSpPr/>
         <p:nvPr/>
       </p:nvGrpSpPr>
-      <p:grpSpPr>
-        <a:xfrm>
-          <a:off x="0" y="0"/>
-          <a:ext cx="0" cy="0"/>
-          <a:chOff x="0" y="0"/>
-          <a:chExt cx="0" cy="0"/>
-        </a:xfrm>
-      </p:grpSpPr>
+      <p:grpSpPr/>
       <p:sp>
         <p:nvSpPr>
           <p:cNvPr id="2" name="Title 1"/>
@@ -3520,76 +3310,46 @@
           <a:bodyPr/>
           <a:lstStyle/>
           <a:p>
-            <a:pPr lvl="0" indent="0" marL="0">
-              <a:buNone/>
-            </a:pPr>
-            <a:r>
-              <a:rPr/>
-              <a:t>Slide 4: Algorithms Used</a:t>
-            </a:r>
-          </a:p>
-        </p:txBody>
-      </p:sp>
-      <p:sp>
-        <p:nvSpPr>
-          <p:cNvPr id="3" name="Content Placeholder 2"/>
-          <p:cNvSpPr>
-            <a:spLocks noGrp="1"/>
-          </p:cNvSpPr>
-          <p:nvPr>
-            <p:ph idx="1"/>
-          </p:nvPr>
-        </p:nvSpPr>
-        <p:spPr/>
-        <p:txBody>
-          <a:bodyPr/>
-          <a:lstStyle/>
-          <a:p>
-            <a:pPr lvl="0" indent="0" marL="0">
-              <a:buNone/>
-            </a:pPr>
-            <a:r>
-              <a:rPr b="1"/>
-              <a:t>1. Logistic Regression (Parametric)</a:t>
-            </a:r>
-            <a:r>
-              <a:rPr/>
-              <a:t> - Fast, highly interpretable, performs well on sparse text data. </a:t>
-            </a:r>
-            <a:r>
-              <a:rPr b="1"/>
-              <a:t>2. Random Forest (Ensemble)</a:t>
-            </a:r>
-            <a:r>
-              <a:rPr/>
-              <a:t> - Robust to noise, captures non-linear patterns, provides feature importance. </a:t>
-            </a:r>
-            <a:r>
-              <a:rPr b="1"/>
-              <a:t>3. K-Nearest Neighbors (Instance-based)</a:t>
-            </a:r>
-            <a:r>
-              <a:rPr/>
-              <a:t> - Lazy learning, classifies based on proximity in feature space. </a:t>
-            </a:r>
-            <a:r>
-              <a:rPr b="1"/>
-              <a:t>4. Neural Network / Multi-Layer Perceptron (Deep Learning)</a:t>
-            </a:r>
-            <a:r>
-              <a:rPr/>
-              <a:t> - Models complex interactions between words using hidden layers and non-linear activations.</a:t>
-            </a:r>
-          </a:p>
-        </p:txBody>
-      </p:sp>
+            <a:r>
+              <a:t>Model Evaluation (Confusion Matrix)</a:t>
+            </a:r>
+          </a:p>
+        </p:txBody>
+      </p:sp>
+      <p:pic>
+        <p:nvPicPr>
+          <p:cNvPr id="3" name="Picture 2" descr="confusion_matrix.png"/>
+          <p:cNvPicPr>
+            <a:picLocks noChangeAspect="1"/>
+          </p:cNvPicPr>
+          <p:nvPr/>
+        </p:nvPicPr>
+        <p:blipFill>
+          <a:blip r:embed="rId2"/>
+          <a:stretch>
+            <a:fillRect/>
+          </a:stretch>
+        </p:blipFill>
+        <p:spPr>
+          <a:xfrm>
+            <a:off x="2286000" y="1371600"/>
+            <a:ext cx="4572000" cy="3657600"/>
+          </a:xfrm>
+          <a:prstGeom prst="rect">
+            <a:avLst/>
+          </a:prstGeom>
+        </p:spPr>
+      </p:pic>
     </p:spTree>
   </p:cSld>
+  <p:clrMapOvr>
+    <a:masterClrMapping/>
+  </p:clrMapOvr>
 </p:sld>
 </file>
 
-<file path=ppt/slides/slide6.xml><?xml version="1.0" encoding="utf-8"?>
-<p:sld xmlns:a="http://schemas.openxmlformats.org/drawingml/2006/main" xmlns:r="http://schemas.openxmlformats.org/officeDocument/2006/relationships" xmlns:p="http://schemas.openxmlformats.org/presentationml/2006/main">
+<file path=ppt/slides/slide5.xml><?xml version="1.0" encoding="utf-8"?>
+<p:sld xmlns:a="http://schemas.openxmlformats.org/drawingml/2006/main" xmlns:p="http://schemas.openxmlformats.org/presentationml/2006/main" xmlns:r="http://schemas.openxmlformats.org/officeDocument/2006/relationships">
   <p:cSld>
     <p:spTree>
       <p:nvGrpSpPr>
@@ -3597,14 +3357,7 @@
         <p:cNvGrpSpPr/>
         <p:nvPr/>
       </p:nvGrpSpPr>
-      <p:grpSpPr>
-        <a:xfrm>
-          <a:off x="0" y="0"/>
-          <a:ext cx="0" cy="0"/>
-          <a:chOff x="0" y="0"/>
-          <a:chExt cx="0" cy="0"/>
-        </a:xfrm>
-      </p:grpSpPr>
+      <p:grpSpPr/>
       <p:sp>
         <p:nvSpPr>
           <p:cNvPr id="2" name="Title 1"/>
@@ -3620,12 +3373,8 @@
           <a:bodyPr/>
           <a:lstStyle/>
           <a:p>
-            <a:pPr lvl="0" indent="0" marL="0">
-              <a:buNone/>
-            </a:pPr>
-            <a:r>
-              <a:rPr/>
-              <a:t>Slide 5: Results &amp; Performance Comparison</a:t>
+            <a:r>
+              <a:t>Conclusion</a:t>
             </a:r>
           </a:p>
         </p:txBody>
@@ -3640,714 +3389,32 @@
             <p:ph idx="1"/>
           </p:nvPr>
         </p:nvSpPr>
-        <p:spPr>
-          <a:xfrm>
-            <a:off x="457200" y="1193800"/>
-            <a:ext cx="8229600" cy="495300"/>
-          </a:xfrm>
-        </p:spPr>
-        <p:txBody>
-          <a:bodyPr/>
-          <a:lstStyle/>
-          <a:p>
-            <a:pPr lvl="0" indent="0" marL="0">
-              <a:buNone/>
-            </a:pPr>
-            <a:r>
-              <a:rPr b="1"/>
-              <a:t>Evaluation Metrics (Test Set):</a:t>
-            </a:r>
-          </a:p>
-        </p:txBody>
-      </p:sp>
-      <p:graphicFrame>
-        <p:nvGraphicFramePr>
-          <p:cNvPr id="6" name="Content Placeholder 5"/>
-          <p:cNvGraphicFramePr>
-            <a:graphicFrameLocks noGrp="1"/>
-          </p:cNvGraphicFramePr>
-          <p:nvPr>
-            <p:ph idx="1"/>
-          </p:nvPr>
-        </p:nvGraphicFramePr>
-        <p:xfrm>
-          <a:off x="457200" y="1816100"/>
-          <a:ext cx="8229600" cy="1409700"/>
-        </p:xfrm>
-        <a:graphic>
-          <a:graphicData uri="http://schemas.openxmlformats.org/drawingml/2006/table">
-            <a:tbl>
-              <a:tblPr firstRow="1" bandRow="1">
-                <a:tableStyleId>{5C22544A-7EE6-4342-B048-85BDC9FD1C3A}</a:tableStyleId>
-              </a:tblPr>
-              <a:tblGrid>
-                <a:gridCol w="1638300"/>
-                <a:gridCol w="1638300"/>
-                <a:gridCol w="1638300"/>
-                <a:gridCol w="1638300"/>
-                <a:gridCol w="1638300"/>
-              </a:tblGrid>
-              <a:tr h="0">
-                <a:tc>
-                  <a:txBody>
-                    <a:bodyPr/>
-                    <a:lstStyle/>
-                    <a:p>
-                      <a:pPr lvl="0" indent="0" marL="0">
-                        <a:buNone/>
-                      </a:pPr>
-                      <a:r>
-                        <a:rPr/>
-                        <a:t>Model</a:t>
-                      </a:r>
-                    </a:p>
-                  </a:txBody>
-                  <a:tcPr/>
-                </a:tc>
-                <a:tc>
-                  <a:txBody>
-                    <a:bodyPr/>
-                    <a:lstStyle/>
-                    <a:p>
-                      <a:pPr lvl="0" indent="0" marL="0">
-                        <a:buNone/>
-                      </a:pPr>
-                      <a:r>
-                        <a:rPr/>
-                        <a:t>Accuracy</a:t>
-                      </a:r>
-                    </a:p>
-                  </a:txBody>
-                  <a:tcPr/>
-                </a:tc>
-                <a:tc>
-                  <a:txBody>
-                    <a:bodyPr/>
-                    <a:lstStyle/>
-                    <a:p>
-                      <a:pPr lvl="0" indent="0" marL="0">
-                        <a:buNone/>
-                      </a:pPr>
-                      <a:r>
-                        <a:rPr/>
-                        <a:t>Precision</a:t>
-                      </a:r>
-                    </a:p>
-                  </a:txBody>
-                  <a:tcPr/>
-                </a:tc>
-                <a:tc>
-                  <a:txBody>
-                    <a:bodyPr/>
-                    <a:lstStyle/>
-                    <a:p>
-                      <a:pPr lvl="0" indent="0" marL="0">
-                        <a:buNone/>
-                      </a:pPr>
-                      <a:r>
-                        <a:rPr/>
-                        <a:t>Recall</a:t>
-                      </a:r>
-                    </a:p>
-                  </a:txBody>
-                  <a:tcPr/>
-                </a:tc>
-                <a:tc>
-                  <a:txBody>
-                    <a:bodyPr/>
-                    <a:lstStyle/>
-                    <a:p>
-                      <a:pPr lvl="0" indent="0" marL="0">
-                        <a:buNone/>
-                      </a:pPr>
-                      <a:r>
-                        <a:rPr/>
-                        <a:t>F1-Score</a:t>
-                      </a:r>
-                    </a:p>
-                  </a:txBody>
-                  <a:tcPr/>
-                </a:tc>
-              </a:tr>
-              <a:tr h="0">
-                <a:tc>
-                  <a:txBody>
-                    <a:bodyPr/>
-                    <a:lstStyle/>
-                    <a:p>
-                      <a:pPr lvl="0" indent="0" marL="0">
-                        <a:buNone/>
-                      </a:pPr>
-                      <a:r>
-                        <a:rPr/>
-                        <a:t>KNN</a:t>
-                      </a:r>
-                    </a:p>
-                  </a:txBody>
-                </a:tc>
-                <a:tc>
-                  <a:txBody>
-                    <a:bodyPr/>
-                    <a:lstStyle/>
-                    <a:p>
-                      <a:pPr lvl="0" indent="0" marL="0">
-                        <a:buNone/>
-                      </a:pPr>
-                      <a:r>
-                        <a:rPr/>
-                        <a:t>100%</a:t>
-                      </a:r>
-                    </a:p>
-                  </a:txBody>
-                </a:tc>
-                <a:tc>
-                  <a:txBody>
-                    <a:bodyPr/>
-                    <a:lstStyle/>
-                    <a:p>
-                      <a:pPr lvl="0" indent="0" marL="0">
-                        <a:buNone/>
-                      </a:pPr>
-                      <a:r>
-                        <a:rPr/>
-                        <a:t>100%</a:t>
-                      </a:r>
-                    </a:p>
-                  </a:txBody>
-                </a:tc>
-                <a:tc>
-                  <a:txBody>
-                    <a:bodyPr/>
-                    <a:lstStyle/>
-                    <a:p>
-                      <a:pPr lvl="0" indent="0" marL="0">
-                        <a:buNone/>
-                      </a:pPr>
-                      <a:r>
-                        <a:rPr/>
-                        <a:t>100%</a:t>
-                      </a:r>
-                    </a:p>
-                  </a:txBody>
-                </a:tc>
-                <a:tc>
-                  <a:txBody>
-                    <a:bodyPr/>
-                    <a:lstStyle/>
-                    <a:p>
-                      <a:pPr lvl="0" indent="0" marL="0">
-                        <a:buNone/>
-                      </a:pPr>
-                      <a:r>
-                        <a:rPr/>
-                        <a:t>100%</a:t>
-                      </a:r>
-                    </a:p>
-                  </a:txBody>
-                </a:tc>
-              </a:tr>
-              <a:tr h="0">
-                <a:tc>
-                  <a:txBody>
-                    <a:bodyPr/>
-                    <a:lstStyle/>
-                    <a:p>
-                      <a:pPr lvl="0" indent="0" marL="0">
-                        <a:buNone/>
-                      </a:pPr>
-                      <a:r>
-                        <a:rPr/>
-                        <a:t>Logistic Regression</a:t>
-                      </a:r>
-                    </a:p>
-                  </a:txBody>
-                </a:tc>
-                <a:tc>
-                  <a:txBody>
-                    <a:bodyPr/>
-                    <a:lstStyle/>
-                    <a:p>
-                      <a:pPr lvl="0" indent="0" marL="0">
-                        <a:buNone/>
-                      </a:pPr>
-                      <a:r>
-                        <a:rPr/>
-                        <a:t>100%</a:t>
-                      </a:r>
-                    </a:p>
-                  </a:txBody>
-                </a:tc>
-                <a:tc>
-                  <a:txBody>
-                    <a:bodyPr/>
-                    <a:lstStyle/>
-                    <a:p>
-                      <a:pPr lvl="0" indent="0" marL="0">
-                        <a:buNone/>
-                      </a:pPr>
-                      <a:r>
-                        <a:rPr/>
-                        <a:t>100%</a:t>
-                      </a:r>
-                    </a:p>
-                  </a:txBody>
-                </a:tc>
-                <a:tc>
-                  <a:txBody>
-                    <a:bodyPr/>
-                    <a:lstStyle/>
-                    <a:p>
-                      <a:pPr lvl="0" indent="0" marL="0">
-                        <a:buNone/>
-                      </a:pPr>
-                      <a:r>
-                        <a:rPr/>
-                        <a:t>100%</a:t>
-                      </a:r>
-                    </a:p>
-                  </a:txBody>
-                </a:tc>
-                <a:tc>
-                  <a:txBody>
-                    <a:bodyPr/>
-                    <a:lstStyle/>
-                    <a:p>
-                      <a:pPr lvl="0" indent="0" marL="0">
-                        <a:buNone/>
-                      </a:pPr>
-                      <a:r>
-                        <a:rPr/>
-                        <a:t>100%</a:t>
-                      </a:r>
-                    </a:p>
-                  </a:txBody>
-                </a:tc>
-              </a:tr>
-              <a:tr h="0">
-                <a:tc>
-                  <a:txBody>
-                    <a:bodyPr/>
-                    <a:lstStyle/>
-                    <a:p>
-                      <a:pPr lvl="0" indent="0" marL="0">
-                        <a:buNone/>
-                      </a:pPr>
-                      <a:r>
-                        <a:rPr/>
-                        <a:t>Random Forest</a:t>
-                      </a:r>
-                    </a:p>
-                  </a:txBody>
-                </a:tc>
-                <a:tc>
-                  <a:txBody>
-                    <a:bodyPr/>
-                    <a:lstStyle/>
-                    <a:p>
-                      <a:pPr lvl="0" indent="0" marL="0">
-                        <a:buNone/>
-                      </a:pPr>
-                      <a:r>
-                        <a:rPr/>
-                        <a:t>100%</a:t>
-                      </a:r>
-                    </a:p>
-                  </a:txBody>
-                </a:tc>
-                <a:tc>
-                  <a:txBody>
-                    <a:bodyPr/>
-                    <a:lstStyle/>
-                    <a:p>
-                      <a:pPr lvl="0" indent="0" marL="0">
-                        <a:buNone/>
-                      </a:pPr>
-                      <a:r>
-                        <a:rPr/>
-                        <a:t>100%</a:t>
-                      </a:r>
-                    </a:p>
-                  </a:txBody>
-                </a:tc>
-                <a:tc>
-                  <a:txBody>
-                    <a:bodyPr/>
-                    <a:lstStyle/>
-                    <a:p>
-                      <a:pPr lvl="0" indent="0" marL="0">
-                        <a:buNone/>
-                      </a:pPr>
-                      <a:r>
-                        <a:rPr/>
-                        <a:t>100%</a:t>
-                      </a:r>
-                    </a:p>
-                  </a:txBody>
-                </a:tc>
-                <a:tc>
-                  <a:txBody>
-                    <a:bodyPr/>
-                    <a:lstStyle/>
-                    <a:p>
-                      <a:pPr lvl="0" indent="0" marL="0">
-                        <a:buNone/>
-                      </a:pPr>
-                      <a:r>
-                        <a:rPr/>
-                        <a:t>100%</a:t>
-                      </a:r>
-                    </a:p>
-                  </a:txBody>
-                </a:tc>
-              </a:tr>
-              <a:tr h="0">
-                <a:tc>
-                  <a:txBody>
-                    <a:bodyPr/>
-                    <a:lstStyle/>
-                    <a:p>
-                      <a:pPr lvl="0" indent="0" marL="0">
-                        <a:buNone/>
-                      </a:pPr>
-                      <a:r>
-                        <a:rPr/>
-                        <a:t>Neural Network</a:t>
-                      </a:r>
-                    </a:p>
-                  </a:txBody>
-                </a:tc>
-                <a:tc>
-                  <a:txBody>
-                    <a:bodyPr/>
-                    <a:lstStyle/>
-                    <a:p>
-                      <a:pPr lvl="0" indent="0" marL="0">
-                        <a:buNone/>
-                      </a:pPr>
-                      <a:r>
-                        <a:rPr/>
-                        <a:t>100%</a:t>
-                      </a:r>
-                    </a:p>
-                  </a:txBody>
-                </a:tc>
-                <a:tc>
-                  <a:txBody>
-                    <a:bodyPr/>
-                    <a:lstStyle/>
-                    <a:p>
-                      <a:pPr lvl="0" indent="0" marL="0">
-                        <a:buNone/>
-                      </a:pPr>
-                      <a:r>
-                        <a:rPr/>
-                        <a:t>100%</a:t>
-                      </a:r>
-                    </a:p>
-                  </a:txBody>
-                </a:tc>
-                <a:tc>
-                  <a:txBody>
-                    <a:bodyPr/>
-                    <a:lstStyle/>
-                    <a:p>
-                      <a:pPr lvl="0" indent="0" marL="0">
-                        <a:buNone/>
-                      </a:pPr>
-                      <a:r>
-                        <a:rPr/>
-                        <a:t>100%</a:t>
-                      </a:r>
-                    </a:p>
-                  </a:txBody>
-                </a:tc>
-                <a:tc>
-                  <a:txBody>
-                    <a:bodyPr/>
-                    <a:lstStyle/>
-                    <a:p>
-                      <a:pPr lvl="0" indent="0" marL="0">
-                        <a:buNone/>
-                      </a:pPr>
-                      <a:r>
-                        <a:rPr/>
-                        <a:t>100%</a:t>
-                      </a:r>
-                    </a:p>
-                  </a:txBody>
-                </a:tc>
-              </a:tr>
-            </a:tbl>
-          </a:graphicData>
-        </a:graphic>
-      </p:graphicFrame>
-      <p:sp>
-        <p:nvSpPr>
-          <p:cNvPr id="3" name="Content Placeholder 2"/>
-          <p:cNvSpPr>
-            <a:spLocks noGrp="1"/>
-          </p:cNvSpPr>
-          <p:nvPr>
-            <p:ph idx="1"/>
-          </p:nvPr>
-        </p:nvSpPr>
-        <p:spPr>
-          <a:xfrm>
-            <a:off x="457200" y="3352800"/>
-            <a:ext cx="8229600" cy="1104900"/>
-          </a:xfrm>
-        </p:spPr>
-        <p:txBody>
-          <a:bodyPr/>
-          <a:lstStyle/>
-          <a:p>
-            <a:pPr lvl="0" indent="0" marL="0">
-              <a:buNone/>
-            </a:pPr>
-            <a:r>
-              <a:rPr b="1"/>
-              <a:t>Key Finding:</a:t>
-            </a:r>
-            <a:r>
-              <a:rPr/>
-              <a:t> - The use of Character N-Grams made all models extremely robust. - Logistic Regression was selected for the final deployment due to its perfect accuracy combined with blazing-fast inference time and high interpretability.</a:t>
-            </a:r>
-          </a:p>
-          <a:p>
-            <a:pPr lvl="0" indent="0" marL="0">
-              <a:buNone/>
-            </a:pPr>
-            <a:r>
-              <a:rPr i="1"/>
-              <a:t>(Include Confusion Matrix or Bar Chart here)</a:t>
+        <p:spPr/>
+        <p:txBody>
+          <a:bodyPr/>
+          <a:lstStyle/>
+          <a:p>
+            <a:r>
+              <a:t>• The system successfully classifies raw text with near-perfect accuracy.</a:t>
+            </a:r>
+          </a:p>
+          <a:p>
+            <a:r>
+              <a:t>• TF-IDF feature extraction is highly effective for this problem domain.</a:t>
+            </a:r>
+          </a:p>
+          <a:p>
+            <a:r>
+              <a:t>• The Streamlit web application provides a seamless user interface for real-time predictions.</a:t>
             </a:r>
           </a:p>
         </p:txBody>
       </p:sp>
     </p:spTree>
   </p:cSld>
-</p:sld>
-</file>
-
-<file path=ppt/slides/slide7.xml><?xml version="1.0" encoding="utf-8"?>
-<p:sld xmlns:a="http://schemas.openxmlformats.org/drawingml/2006/main" xmlns:r="http://schemas.openxmlformats.org/officeDocument/2006/relationships" xmlns:p="http://schemas.openxmlformats.org/presentationml/2006/main">
-  <p:cSld>
-    <p:spTree>
-      <p:nvGrpSpPr>
-        <p:cNvPr id="1" name=""/>
-        <p:cNvGrpSpPr/>
-        <p:nvPr/>
-      </p:nvGrpSpPr>
-      <p:grpSpPr>
-        <a:xfrm>
-          <a:off x="0" y="0"/>
-          <a:ext cx="0" cy="0"/>
-          <a:chOff x="0" y="0"/>
-          <a:chExt cx="0" cy="0"/>
-        </a:xfrm>
-      </p:grpSpPr>
-      <p:sp>
-        <p:nvSpPr>
-          <p:cNvPr id="2" name="Title 1"/>
-          <p:cNvSpPr>
-            <a:spLocks noGrp="1"/>
-          </p:cNvSpPr>
-          <p:nvPr>
-            <p:ph type="title"/>
-          </p:nvPr>
-        </p:nvSpPr>
-        <p:spPr/>
-        <p:txBody>
-          <a:bodyPr/>
-          <a:lstStyle/>
-          <a:p>
-            <a:pPr lvl="0" indent="0" marL="0">
-              <a:buNone/>
-            </a:pPr>
-            <a:r>
-              <a:rPr/>
-              <a:t>Slide 6: Demo</a:t>
-            </a:r>
-          </a:p>
-        </p:txBody>
-      </p:sp>
-      <p:sp>
-        <p:nvSpPr>
-          <p:cNvPr id="3" name="Content Placeholder 2"/>
-          <p:cNvSpPr>
-            <a:spLocks noGrp="1"/>
-          </p:cNvSpPr>
-          <p:nvPr>
-            <p:ph idx="1"/>
-          </p:nvPr>
-        </p:nvSpPr>
-        <p:spPr/>
-        <p:txBody>
-          <a:bodyPr/>
-          <a:lstStyle/>
-          <a:p>
-            <a:pPr lvl="0" indent="0" marL="0">
-              <a:buNone/>
-            </a:pPr>
-            <a:r>
-              <a:rPr b="1"/>
-              <a:t>Interactive Web Application (Streamlit)</a:t>
-            </a:r>
-            <a:r>
-              <a:rPr/>
-              <a:t> - </a:t>
-            </a:r>
-            <a:r>
-              <a:rPr b="1"/>
-              <a:t>Input:</a:t>
-            </a:r>
-            <a:r>
-              <a:rPr/>
-              <a:t> User pastes a news headline or article. - </a:t>
-            </a:r>
-            <a:r>
-              <a:rPr b="1"/>
-              <a:t>Process:</a:t>
-            </a:r>
-            <a:r>
-              <a:rPr/>
-              <a:t> The text undergoes real-time cleaning and TF-IDF transformation. - </a:t>
-            </a:r>
-            <a:r>
-              <a:rPr b="1"/>
-              <a:t>Output:</a:t>
-            </a:r>
-            <a:r>
-              <a:rPr/>
-              <a:t> The model predicts “FAKE NEWS” or “REAL NEWS” with a confidence score.</a:t>
-            </a:r>
-          </a:p>
-          <a:p>
-            <a:pPr lvl="0" indent="0" marL="0">
-              <a:buNone/>
-            </a:pPr>
-            <a:r>
-              <a:rPr i="1"/>
-              <a:t>(Insert Screenshots of the Streamlit App: One showing a FAKE prediction, one showing a REAL prediction)</a:t>
-            </a:r>
-          </a:p>
-        </p:txBody>
-      </p:sp>
-    </p:spTree>
-  </p:cSld>
-</p:sld>
-</file>
-
-<file path=ppt/slides/slide8.xml><?xml version="1.0" encoding="utf-8"?>
-<p:sld xmlns:a="http://schemas.openxmlformats.org/drawingml/2006/main" xmlns:r="http://schemas.openxmlformats.org/officeDocument/2006/relationships" xmlns:p="http://schemas.openxmlformats.org/presentationml/2006/main">
-  <p:cSld>
-    <p:spTree>
-      <p:nvGrpSpPr>
-        <p:cNvPr id="1" name=""/>
-        <p:cNvGrpSpPr/>
-        <p:nvPr/>
-      </p:nvGrpSpPr>
-      <p:grpSpPr>
-        <a:xfrm>
-          <a:off x="0" y="0"/>
-          <a:ext cx="0" cy="0"/>
-          <a:chOff x="0" y="0"/>
-          <a:chExt cx="0" cy="0"/>
-        </a:xfrm>
-      </p:grpSpPr>
-      <p:sp>
-        <p:nvSpPr>
-          <p:cNvPr id="2" name="Title 1"/>
-          <p:cNvSpPr>
-            <a:spLocks noGrp="1"/>
-          </p:cNvSpPr>
-          <p:nvPr>
-            <p:ph type="title"/>
-          </p:nvPr>
-        </p:nvSpPr>
-        <p:spPr/>
-        <p:txBody>
-          <a:bodyPr/>
-          <a:lstStyle/>
-          <a:p>
-            <a:pPr lvl="0" indent="0" marL="0">
-              <a:buNone/>
-            </a:pPr>
-            <a:r>
-              <a:rPr/>
-              <a:t>Slide 7: Conclusion &amp; Future Scope</a:t>
-            </a:r>
-          </a:p>
-        </p:txBody>
-      </p:sp>
-      <p:sp>
-        <p:nvSpPr>
-          <p:cNvPr id="3" name="Content Placeholder 2"/>
-          <p:cNvSpPr>
-            <a:spLocks noGrp="1"/>
-          </p:cNvSpPr>
-          <p:nvPr>
-            <p:ph idx="1"/>
-          </p:nvPr>
-        </p:nvSpPr>
-        <p:spPr/>
-        <p:txBody>
-          <a:bodyPr/>
-          <a:lstStyle/>
-          <a:p>
-            <a:pPr lvl="0" indent="0" marL="0">
-              <a:buNone/>
-            </a:pPr>
-            <a:r>
-              <a:rPr b="1"/>
-              <a:t>Conclusion:</a:t>
-            </a:r>
-            <a:r>
-              <a:rPr/>
-              <a:t> - Successfully built an end-to-end NLP pipeline that accurately classifies text. - Character N-Grams proved highly effective at handling novel text structures and typos. - The deployed web module proves the feasibility of real-time AI fact-checking.</a:t>
-            </a:r>
-          </a:p>
-          <a:p>
-            <a:pPr lvl="0" indent="0" marL="0">
-              <a:buNone/>
-            </a:pPr>
-            <a:r>
-              <a:rPr b="1"/>
-              <a:t>Future Scope:</a:t>
-            </a:r>
-            <a:r>
-              <a:rPr/>
-              <a:t> - </a:t>
-            </a:r>
-            <a:r>
-              <a:rPr b="1"/>
-              <a:t>Contextual Embeddings:</a:t>
-            </a:r>
-            <a:r>
-              <a:rPr/>
-              <a:t> Upgrade to Transformer models (BERT, RoBERTa) for deeper semantic understanding. - </a:t>
-            </a:r>
-            <a:r>
-              <a:rPr b="1"/>
-              <a:t>Live Fact-Checking:</a:t>
-            </a:r>
-            <a:r>
-              <a:rPr/>
-              <a:t> Integrate with Knowledge Graphs or search APIs to verify actual facts, not just textual style. - </a:t>
-            </a:r>
-            <a:r>
-              <a:rPr b="1"/>
-              <a:t>Browser Extension:</a:t>
-            </a:r>
-            <a:r>
-              <a:rPr/>
-              <a:t> Deploy as a Chrome extension for real-time alerts on social media.</a:t>
-            </a:r>
-          </a:p>
-        </p:txBody>
-      </p:sp>
-    </p:spTree>
-  </p:cSld>
+  <p:clrMapOvr>
+    <a:masterClrMapping/>
+  </p:clrMapOvr>
 </p:sld>
 </file>
 
@@ -4669,265 +3736,4 @@
   </a:objectDefaults>
   <a:extraClrSchemeLst/>
 </a:theme>
-</file>
-
-<file path=ppt/theme/theme2.xml><?xml version="1.0" encoding="utf-8"?>
-<a:theme xmlns:a="http://schemas.openxmlformats.org/drawingml/2006/main" name="Office Theme">
-  <a:themeElements>
-    <a:clrScheme name="Office">
-      <a:dk1>
-        <a:sysClr val="windowText" lastClr="000000"/>
-      </a:dk1>
-      <a:lt1>
-        <a:sysClr val="window" lastClr="FFFFFF"/>
-      </a:lt1>
-      <a:dk2>
-        <a:srgbClr val="44546A"/>
-      </a:dk2>
-      <a:lt2>
-        <a:srgbClr val="E7E6E6"/>
-      </a:lt2>
-      <a:accent1>
-        <a:srgbClr val="5B9BD5"/>
-      </a:accent1>
-      <a:accent2>
-        <a:srgbClr val="ED7D31"/>
-      </a:accent2>
-      <a:accent3>
-        <a:srgbClr val="A5A5A5"/>
-      </a:accent3>
-      <a:accent4>
-        <a:srgbClr val="FFC000"/>
-      </a:accent4>
-      <a:accent5>
-        <a:srgbClr val="4472C4"/>
-      </a:accent5>
-      <a:accent6>
-        <a:srgbClr val="70AD47"/>
-      </a:accent6>
-      <a:hlink>
-        <a:srgbClr val="0563C1"/>
-      </a:hlink>
-      <a:folHlink>
-        <a:srgbClr val="954F72"/>
-      </a:folHlink>
-    </a:clrScheme>
-    <a:fontScheme name="Office">
-      <a:majorFont>
-        <a:latin typeface="Calibri Light" panose="020F0302020204030204"/>
-        <a:ea typeface=""/>
-        <a:cs typeface=""/>
-        <a:font script="Jpan" typeface="ＭＳ Ｐゴシック"/>
-        <a:font script="Hang" typeface="맑은 고딕"/>
-        <a:font script="Hans" typeface="宋体"/>
-        <a:font script="Hant" typeface="新細明體"/>
-        <a:font script="Arab" typeface="Times New Roman"/>
-        <a:font script="Hebr" typeface="Times New Roman"/>
-        <a:font script="Thai" typeface="Angsana New"/>
-        <a:font script="Ethi" typeface="Nyala"/>
-        <a:font script="Beng" typeface="Vrinda"/>
-        <a:font script="Gujr" typeface="Shruti"/>
-        <a:font script="Khmr" typeface="MoolBoran"/>
-        <a:font script="Knda" typeface="Tunga"/>
-        <a:font script="Guru" typeface="Raavi"/>
-        <a:font script="Cans" typeface="Euphemia"/>
-        <a:font script="Cher" typeface="Plantagenet Cherokee"/>
-        <a:font script="Yiii" typeface="Microsoft Yi Baiti"/>
-        <a:font script="Tibt" typeface="Microsoft Himalaya"/>
-        <a:font script="Thaa" typeface="MV Boli"/>
-        <a:font script="Deva" typeface="Mangal"/>
-        <a:font script="Telu" typeface="Gautami"/>
-        <a:font script="Taml" typeface="Latha"/>
-        <a:font script="Syrc" typeface="Estrangelo Edessa"/>
-        <a:font script="Orya" typeface="Kalinga"/>
-        <a:font script="Mlym" typeface="Kartika"/>
-        <a:font script="Laoo" typeface="DokChampa"/>
-        <a:font script="Sinh" typeface="Iskoola Pota"/>
-        <a:font script="Mong" typeface="Mongolian Baiti"/>
-        <a:font script="Viet" typeface="Times New Roman"/>
-        <a:font script="Uigh" typeface="Microsoft Uighur"/>
-        <a:font script="Geor" typeface="Sylfaen"/>
-      </a:majorFont>
-      <a:minorFont>
-        <a:latin typeface="Calibri" panose="020F0502020204030204"/>
-        <a:ea typeface=""/>
-        <a:cs typeface=""/>
-        <a:font script="Jpan" typeface="ＭＳ Ｐゴシック"/>
-        <a:font script="Hang" typeface="맑은 고딕"/>
-        <a:font script="Hans" typeface="宋体"/>
-        <a:font script="Hant" typeface="新細明體"/>
-        <a:font script="Arab" typeface="Arial"/>
-        <a:font script="Hebr" typeface="Arial"/>
-        <a:font script="Thai" typeface="Cordia New"/>
-        <a:font script="Ethi" typeface="Nyala"/>
-        <a:font script="Beng" typeface="Vrinda"/>
-        <a:font script="Gujr" typeface="Shruti"/>
-        <a:font script="Khmr" typeface="DaunPenh"/>
-        <a:font script="Knda" typeface="Tunga"/>
-        <a:font script="Guru" typeface="Raavi"/>
-        <a:font script="Cans" typeface="Euphemia"/>
-        <a:font script="Cher" typeface="Plantagenet Cherokee"/>
-        <a:font script="Yiii" typeface="Microsoft Yi Baiti"/>
-        <a:font script="Tibt" typeface="Microsoft Himalaya"/>
-        <a:font script="Thaa" typeface="MV Boli"/>
-        <a:font script="Deva" typeface="Mangal"/>
-        <a:font script="Telu" typeface="Gautami"/>
-        <a:font script="Taml" typeface="Latha"/>
-        <a:font script="Syrc" typeface="Estrangelo Edessa"/>
-        <a:font script="Orya" typeface="Kalinga"/>
-        <a:font script="Mlym" typeface="Kartika"/>
-        <a:font script="Laoo" typeface="DokChampa"/>
-        <a:font script="Sinh" typeface="Iskoola Pota"/>
-        <a:font script="Mong" typeface="Mongolian Baiti"/>
-        <a:font script="Viet" typeface="Arial"/>
-        <a:font script="Uigh" typeface="Microsoft Uighur"/>
-        <a:font script="Geor" typeface="Sylfaen"/>
-      </a:minorFont>
-    </a:fontScheme>
-    <a:fmtScheme name="Office">
-      <a:fillStyleLst>
-        <a:solidFill>
-          <a:schemeClr val="phClr"/>
-        </a:solidFill>
-        <a:gradFill rotWithShape="1">
-          <a:gsLst>
-            <a:gs pos="0">
-              <a:schemeClr val="phClr">
-                <a:lumMod val="110000"/>
-                <a:satMod val="105000"/>
-                <a:tint val="67000"/>
-              </a:schemeClr>
-            </a:gs>
-            <a:gs pos="50000">
-              <a:schemeClr val="phClr">
-                <a:lumMod val="105000"/>
-                <a:satMod val="103000"/>
-                <a:tint val="73000"/>
-              </a:schemeClr>
-            </a:gs>
-            <a:gs pos="100000">
-              <a:schemeClr val="phClr">
-                <a:lumMod val="105000"/>
-                <a:satMod val="109000"/>
-                <a:tint val="81000"/>
-              </a:schemeClr>
-            </a:gs>
-          </a:gsLst>
-          <a:lin ang="5400000" scaled="0"/>
-        </a:gradFill>
-        <a:gradFill rotWithShape="1">
-          <a:gsLst>
-            <a:gs pos="0">
-              <a:schemeClr val="phClr">
-                <a:satMod val="103000"/>
-                <a:lumMod val="102000"/>
-                <a:tint val="94000"/>
-              </a:schemeClr>
-            </a:gs>
-            <a:gs pos="50000">
-              <a:schemeClr val="phClr">
-                <a:satMod val="110000"/>
-                <a:lumMod val="100000"/>
-                <a:shade val="100000"/>
-              </a:schemeClr>
-            </a:gs>
-            <a:gs pos="100000">
-              <a:schemeClr val="phClr">
-                <a:lumMod val="99000"/>
-                <a:satMod val="120000"/>
-                <a:shade val="78000"/>
-              </a:schemeClr>
-            </a:gs>
-          </a:gsLst>
-          <a:lin ang="5400000" scaled="0"/>
-        </a:gradFill>
-      </a:fillStyleLst>
-      <a:lnStyleLst>
-        <a:ln w="6350" cap="flat" cmpd="sng" algn="ctr">
-          <a:solidFill>
-            <a:schemeClr val="phClr"/>
-          </a:solidFill>
-          <a:prstDash val="solid"/>
-          <a:miter lim="800000"/>
-        </a:ln>
-        <a:ln w="12700" cap="flat" cmpd="sng" algn="ctr">
-          <a:solidFill>
-            <a:schemeClr val="phClr"/>
-          </a:solidFill>
-          <a:prstDash val="solid"/>
-          <a:miter lim="800000"/>
-        </a:ln>
-        <a:ln w="19050" cap="flat" cmpd="sng" algn="ctr">
-          <a:solidFill>
-            <a:schemeClr val="phClr"/>
-          </a:solidFill>
-          <a:prstDash val="solid"/>
-          <a:miter lim="800000"/>
-        </a:ln>
-      </a:lnStyleLst>
-      <a:effectStyleLst>
-        <a:effectStyle>
-          <a:effectLst/>
-        </a:effectStyle>
-        <a:effectStyle>
-          <a:effectLst/>
-        </a:effectStyle>
-        <a:effectStyle>
-          <a:effectLst>
-            <a:outerShdw blurRad="57150" dist="19050" dir="5400000" algn="ctr" rotWithShape="0">
-              <a:srgbClr val="000000">
-                <a:alpha val="63000"/>
-              </a:srgbClr>
-            </a:outerShdw>
-          </a:effectLst>
-        </a:effectStyle>
-      </a:effectStyleLst>
-      <a:bgFillStyleLst>
-        <a:solidFill>
-          <a:schemeClr val="phClr"/>
-        </a:solidFill>
-        <a:solidFill>
-          <a:schemeClr val="phClr">
-            <a:tint val="95000"/>
-            <a:satMod val="170000"/>
-          </a:schemeClr>
-        </a:solidFill>
-        <a:gradFill rotWithShape="1">
-          <a:gsLst>
-            <a:gs pos="0">
-              <a:schemeClr val="phClr">
-                <a:tint val="93000"/>
-                <a:satMod val="150000"/>
-                <a:shade val="98000"/>
-                <a:lumMod val="102000"/>
-              </a:schemeClr>
-            </a:gs>
-            <a:gs pos="50000">
-              <a:schemeClr val="phClr">
-                <a:tint val="98000"/>
-                <a:satMod val="130000"/>
-                <a:shade val="90000"/>
-                <a:lumMod val="103000"/>
-              </a:schemeClr>
-            </a:gs>
-            <a:gs pos="100000">
-              <a:schemeClr val="phClr">
-                <a:shade val="63000"/>
-                <a:satMod val="120000"/>
-              </a:schemeClr>
-            </a:gs>
-          </a:gsLst>
-          <a:lin ang="5400000" scaled="0"/>
-        </a:gradFill>
-      </a:bgFillStyleLst>
-    </a:fmtScheme>
-  </a:themeElements>
-  <a:objectDefaults/>
-  <a:extraClrSchemeLst/>
-  <a:extLst>
-    <a:ext uri="{05A4C25C-085E-4340-85A3-A5531E510DB2}">
-      <thm15:themeFamily xmlns:thm15="http://schemas.microsoft.com/office/thememl/2012/main" name="Office Theme" id="{62F939B6-93AF-4DB8-9C6B-D6C7DFDC589F}" vid="{4A3C46E8-61CC-4603-A589-7422A47A8E4A}"/>
-    </a:ext>
-  </a:extLst>
-</a:theme>
 </file>
</xml_diff>

<commit_message>
Generate actual workflow flowchart image and restore sample outputs to ppt
</commit_message>
<xml_diff>
--- a/Final_Internship_Submission/Project_1_Fake_News/fake_news_project_ppt.pptx
+++ b/Final_Internship_Submission/Project_1_Fake_News/fake_news_project_ppt.pptx
@@ -10,6 +10,7 @@
     <p:sldId id="258" r:id="rId9"/>
     <p:sldId id="259" r:id="rId10"/>
     <p:sldId id="260" r:id="rId11"/>
+    <p:sldId id="261" r:id="rId12"/>
   </p:sldIdLst>
   <p:sldSz cx="9144000" cy="6858000" type="screen4x3"/>
   <p:notesSz cx="6858000" cy="9144000"/>
@@ -3108,7 +3109,7 @@
           <a:lstStyle/>
           <a:p>
             <a:r>
-              <a:t>AI-Powered Fake News Detection Using Text Classification</a:t>
+              <a:t>AI-Powered Fake News Detection</a:t>
             </a:r>
           </a:p>
         </p:txBody>
@@ -3349,6 +3350,92 @@
 </file>
 
 <file path=ppt/slides/slide5.xml><?xml version="1.0" encoding="utf-8"?>
+<p:sld xmlns:a="http://schemas.openxmlformats.org/drawingml/2006/main" xmlns:p="http://schemas.openxmlformats.org/presentationml/2006/main" xmlns:r="http://schemas.openxmlformats.org/officeDocument/2006/relationships">
+  <p:cSld>
+    <p:spTree>
+      <p:nvGrpSpPr>
+        <p:cNvPr id="1" name=""/>
+        <p:cNvGrpSpPr/>
+        <p:nvPr/>
+      </p:nvGrpSpPr>
+      <p:grpSpPr/>
+      <p:sp>
+        <p:nvSpPr>
+          <p:cNvPr id="2" name="Title 1"/>
+          <p:cNvSpPr>
+            <a:spLocks noGrp="1"/>
+          </p:cNvSpPr>
+          <p:nvPr>
+            <p:ph type="title"/>
+          </p:nvPr>
+        </p:nvSpPr>
+        <p:spPr/>
+        <p:txBody>
+          <a:bodyPr/>
+          <a:lstStyle/>
+          <a:p>
+            <a:r>
+              <a:t>Sample Inputs &amp; Outputs</a:t>
+            </a:r>
+          </a:p>
+        </p:txBody>
+      </p:sp>
+      <p:sp>
+        <p:nvSpPr>
+          <p:cNvPr id="3" name="Content Placeholder 2"/>
+          <p:cNvSpPr>
+            <a:spLocks noGrp="1"/>
+          </p:cNvSpPr>
+          <p:nvPr>
+            <p:ph idx="1"/>
+          </p:nvPr>
+        </p:nvSpPr>
+        <p:spPr/>
+        <p:txBody>
+          <a:bodyPr/>
+          <a:lstStyle/>
+          <a:p>
+            <a:r>
+              <a:t>TEST 1 (Fake News):</a:t>
+            </a:r>
+          </a:p>
+          <a:p>
+            <a:r>
+              <a:t>Input: "BREAKING: Aliens land in New York, government hides evidence!"</a:t>
+            </a:r>
+          </a:p>
+          <a:p>
+            <a:r>
+              <a:t>Output: Predicted as FAKE</a:t>
+            </a:r>
+          </a:p>
+          <a:p/>
+          <a:p>
+            <a:r>
+              <a:t>TEST 2 (Real News):</a:t>
+            </a:r>
+          </a:p>
+          <a:p>
+            <a:r>
+              <a:t>Input: "The stock market saw a slight decline today due to inflation concerns."</a:t>
+            </a:r>
+          </a:p>
+          <a:p>
+            <a:r>
+              <a:t>Output: Predicted as REAL</a:t>
+            </a:r>
+          </a:p>
+        </p:txBody>
+      </p:sp>
+    </p:spTree>
+  </p:cSld>
+  <p:clrMapOvr>
+    <a:masterClrMapping/>
+  </p:clrMapOvr>
+</p:sld>
+</file>
+
+<file path=ppt/slides/slide6.xml><?xml version="1.0" encoding="utf-8"?>
 <p:sld xmlns:a="http://schemas.openxmlformats.org/drawingml/2006/main" xmlns:p="http://schemas.openxmlformats.org/presentationml/2006/main" xmlns:r="http://schemas.openxmlformats.org/officeDocument/2006/relationships">
   <p:cSld>
     <p:spTree>

</xml_diff>

<commit_message>
Restore original massive 20-page reports and presentations, delete dummy generators, and package clean zip file
</commit_message>
<xml_diff>
--- a/Final_Internship_Submission/Project_1_Fake_News/fake_news_project_ppt.pptx
+++ b/Final_Internship_Submission/Project_1_Fake_News/fake_news_project_ppt.pptx
@@ -3145,6 +3145,30 @@
           </a:p>
         </p:txBody>
       </p:sp>
+      <p:pic>
+        <p:nvPicPr>
+          <p:cNvPr id="4" name="Picture 3" descr="iict_logo.png"/>
+          <p:cNvPicPr>
+            <a:picLocks noChangeAspect="1"/>
+          </p:cNvPicPr>
+          <p:nvPr/>
+        </p:nvPicPr>
+        <p:blipFill>
+          <a:blip r:embed="rId2"/>
+          <a:stretch>
+            <a:fillRect/>
+          </a:stretch>
+        </p:blipFill>
+        <p:spPr>
+          <a:xfrm>
+            <a:off x="457200" y="457200"/>
+            <a:ext cx="1371600" cy="918594"/>
+          </a:xfrm>
+          <a:prstGeom prst="rect">
+            <a:avLst/>
+          </a:prstGeom>
+        </p:spPr>
+      </p:pic>
     </p:spTree>
   </p:cSld>
   <p:clrMapOvr>
@@ -3215,6 +3239,30 @@
           </a:p>
         </p:txBody>
       </p:sp>
+      <p:pic>
+        <p:nvPicPr>
+          <p:cNvPr id="4" name="Picture 3" descr="iict_logo.png"/>
+          <p:cNvPicPr>
+            <a:picLocks noChangeAspect="1"/>
+          </p:cNvPicPr>
+          <p:nvPr/>
+        </p:nvPicPr>
+        <p:blipFill>
+          <a:blip r:embed="rId2"/>
+          <a:stretch>
+            <a:fillRect/>
+          </a:stretch>
+        </p:blipFill>
+        <p:spPr>
+          <a:xfrm>
+            <a:off x="7772400" y="182880"/>
+            <a:ext cx="914400" cy="612396"/>
+          </a:xfrm>
+          <a:prstGeom prst="rect">
+            <a:avLst/>
+          </a:prstGeom>
+        </p:spPr>
+      </p:pic>
     </p:spTree>
   </p:cSld>
   <p:clrMapOvr>
@@ -3278,6 +3326,30 @@
           </a:prstGeom>
         </p:spPr>
       </p:pic>
+      <p:pic>
+        <p:nvPicPr>
+          <p:cNvPr id="4" name="Picture 3" descr="iict_logo.png"/>
+          <p:cNvPicPr>
+            <a:picLocks noChangeAspect="1"/>
+          </p:cNvPicPr>
+          <p:nvPr/>
+        </p:nvPicPr>
+        <p:blipFill>
+          <a:blip r:embed="rId3"/>
+          <a:stretch>
+            <a:fillRect/>
+          </a:stretch>
+        </p:blipFill>
+        <p:spPr>
+          <a:xfrm>
+            <a:off x="7772400" y="182880"/>
+            <a:ext cx="914400" cy="612396"/>
+          </a:xfrm>
+          <a:prstGeom prst="rect">
+            <a:avLst/>
+          </a:prstGeom>
+        </p:spPr>
+      </p:pic>
     </p:spTree>
   </p:cSld>
   <p:clrMapOvr>
@@ -3341,6 +3413,30 @@
           </a:prstGeom>
         </p:spPr>
       </p:pic>
+      <p:pic>
+        <p:nvPicPr>
+          <p:cNvPr id="4" name="Picture 3" descr="iict_logo.png"/>
+          <p:cNvPicPr>
+            <a:picLocks noChangeAspect="1"/>
+          </p:cNvPicPr>
+          <p:nvPr/>
+        </p:nvPicPr>
+        <p:blipFill>
+          <a:blip r:embed="rId3"/>
+          <a:stretch>
+            <a:fillRect/>
+          </a:stretch>
+        </p:blipFill>
+        <p:spPr>
+          <a:xfrm>
+            <a:off x="7772400" y="182880"/>
+            <a:ext cx="914400" cy="612396"/>
+          </a:xfrm>
+          <a:prstGeom prst="rect">
+            <a:avLst/>
+          </a:prstGeom>
+        </p:spPr>
+      </p:pic>
     </p:spTree>
   </p:cSld>
   <p:clrMapOvr>
@@ -3427,6 +3523,30 @@
           </a:p>
         </p:txBody>
       </p:sp>
+      <p:pic>
+        <p:nvPicPr>
+          <p:cNvPr id="4" name="Picture 3" descr="iict_logo.png"/>
+          <p:cNvPicPr>
+            <a:picLocks noChangeAspect="1"/>
+          </p:cNvPicPr>
+          <p:nvPr/>
+        </p:nvPicPr>
+        <p:blipFill>
+          <a:blip r:embed="rId2"/>
+          <a:stretch>
+            <a:fillRect/>
+          </a:stretch>
+        </p:blipFill>
+        <p:spPr>
+          <a:xfrm>
+            <a:off x="7772400" y="182880"/>
+            <a:ext cx="914400" cy="612396"/>
+          </a:xfrm>
+          <a:prstGeom prst="rect">
+            <a:avLst/>
+          </a:prstGeom>
+        </p:spPr>
+      </p:pic>
     </p:spTree>
   </p:cSld>
   <p:clrMapOvr>
@@ -3497,6 +3617,30 @@
           </a:p>
         </p:txBody>
       </p:sp>
+      <p:pic>
+        <p:nvPicPr>
+          <p:cNvPr id="4" name="Picture 3" descr="iict_logo.png"/>
+          <p:cNvPicPr>
+            <a:picLocks noChangeAspect="1"/>
+          </p:cNvPicPr>
+          <p:nvPr/>
+        </p:nvPicPr>
+        <p:blipFill>
+          <a:blip r:embed="rId2"/>
+          <a:stretch>
+            <a:fillRect/>
+          </a:stretch>
+        </p:blipFill>
+        <p:spPr>
+          <a:xfrm>
+            <a:off x="7772400" y="182880"/>
+            <a:ext cx="914400" cy="612396"/>
+          </a:xfrm>
+          <a:prstGeom prst="rect">
+            <a:avLst/>
+          </a:prstGeom>
+        </p:spPr>
+      </p:pic>
     </p:spTree>
   </p:cSld>
   <p:clrMapOvr>

</xml_diff>